<commit_message>
Added awareness page and updated login logging
</commit_message>
<xml_diff>
--- a/Abdul_Basit_Phishing_Awareness_Presentation copy.pptx
+++ b/Abdul_Basit_Phishing_Awareness_Presentation copy.pptx
@@ -4,6 +4,9 @@
   <p:sldMasterIdLst>
     <p:sldMasterId id="2147483648" r:id="rId1"/>
   </p:sldMasterIdLst>
+  <p:notesMasterIdLst>
+    <p:notesMasterId r:id="rId16"/>
+  </p:notesMasterIdLst>
   <p:sldIdLst>
     <p:sldId id="256" r:id="rId2"/>
     <p:sldId id="257" r:id="rId3"/>
@@ -20,11 +23,8 @@
     <p:sldId id="268" r:id="rId14"/>
     <p:sldId id="269" r:id="rId15"/>
   </p:sldIdLst>
-  <p:notesMasterIdLst>
-    <p:notesMasterId r:id="rId16"/>
-  </p:notesMasterIdLst>
-  <p:sldSz cx="12191695" cy="6858000"/>
-  <p:notesSz cx="6858000" cy="12191695"/>
+  <p:sldSz cx="12192000" cy="6858000"/>
+  <p:notesSz cx="6858000" cy="12192000"/>
   <p:defaultTextStyle>
     <a:lvl1pPr marL="0" algn="l" defTabSz="914400" rtl="0" eaLnBrk="1" latinLnBrk="0" hangingPunct="1">
       <a:defRPr sz="1800" kern="1200">
@@ -117,6 +117,11 @@
       </a:defRPr>
     </a:lvl9pPr>
   </p:defaultTextStyle>
+  <p:extLst>
+    <p:ext uri="{EFAFB233-063F-42B5-8137-9DF3F51BA10A}">
+      <p15:sldGuideLst xmlns:p15="http://schemas.microsoft.com/office/powerpoint/2012/main"/>
+    </p:ext>
+  </p:extLst>
 </p:presentation>
 </file>
 
@@ -142,234 +147,10 @@
           <a:chExt cx="0" cy="0"/>
         </a:xfrm>
       </p:grpSpPr>
-      <p:sp>
-        <p:nvSpPr>
-          <p:cNvPr id="2" name="Header Placeholder 1"/>
-          <p:cNvSpPr>
-            <a:spLocks noGrp="1"/>
-          </p:cNvSpPr>
-          <p:nvPr>
-            <p:ph type="hdr" sz="quarter"/>
-          </p:nvPr>
-        </p:nvSpPr>
-        <p:spPr>
-          <a:xfrm>
-            <a:off x="0" y="0"/>
-            <a:ext cx="2971800" cy="458788"/>
-          </a:xfrm>
-          <a:prstGeom prst="rect">
-            <a:avLst/>
-          </a:prstGeom>
-        </p:spPr>
-        <p:txBody>
-          <a:bodyPr vert="horz" lIns="91440" tIns="45720" rIns="91440" bIns="45720" rtlCol="0"/>
-          <a:lstStyle>
-            <a:lvl1pPr algn="l">
-              <a:defRPr sz="1200"/>
-            </a:lvl1pPr>
-          </a:lstStyle>
-          <a:p>
-            <a:endParaRPr lang="en-US"/>
-          </a:p>
-        </p:txBody>
-      </p:sp>
-      <p:sp>
-        <p:nvSpPr>
-          <p:cNvPr id="3" name="Date Placeholder 2"/>
-          <p:cNvSpPr>
-            <a:spLocks noGrp="1"/>
-          </p:cNvSpPr>
-          <p:nvPr>
-            <p:ph type="dt" idx="1"/>
-          </p:nvPr>
-        </p:nvSpPr>
-        <p:spPr>
-          <a:xfrm>
-            <a:off x="3884613" y="0"/>
-            <a:ext cx="2971800" cy="458788"/>
-          </a:xfrm>
-          <a:prstGeom prst="rect">
-            <a:avLst/>
-          </a:prstGeom>
-        </p:spPr>
-        <p:txBody>
-          <a:bodyPr vert="horz" lIns="91440" tIns="45720" rIns="91440" bIns="45720" rtlCol="0"/>
-          <a:lstStyle>
-            <a:lvl1pPr algn="r">
-              <a:defRPr sz="1200"/>
-            </a:lvl1pPr>
-          </a:lstStyle>
-          <a:p>
-            <a:fld id="{5282F153-3F37-0F45-9E97-73ACFA13230C}" type="datetimeFigureOut">
-              <a:rPr lang="en-US"/>
-              <a:t>7/23/19</a:t>
-            </a:fld>
-            <a:endParaRPr lang="en-US"/>
-          </a:p>
-        </p:txBody>
-      </p:sp>
-      <p:sp>
-        <p:nvSpPr>
-          <p:cNvPr id="4" name="Slide Image Placeholder 3"/>
-          <p:cNvSpPr>
-            <a:spLocks noGrp="1" noRot="1" noChangeAspect="1"/>
-          </p:cNvSpPr>
-          <p:nvPr>
-            <p:ph type="sldImg" idx="2"/>
-          </p:nvPr>
-        </p:nvSpPr>
-        <p:spPr>
-          <a:xfrm>
-            <a:off x="685800" y="1143000"/>
-            <a:ext cx="5486400" cy="3086100"/>
-          </a:xfrm>
-          <a:prstGeom prst="rect">
-            <a:avLst/>
-          </a:prstGeom>
-          <a:noFill/>
-          <a:ln w="12700">
-            <a:solidFill>
-              <a:prstClr val="black"/>
-            </a:solidFill>
-          </a:ln>
-        </p:spPr>
-        <p:txBody>
-          <a:bodyPr vert="horz" lIns="91440" tIns="45720" rIns="91440" bIns="45720" rtlCol="0" anchor="ctr"/>
-          <a:lstStyle/>
-          <a:p>
-            <a:endParaRPr lang="en-US"/>
-          </a:p>
-        </p:txBody>
-      </p:sp>
-      <p:sp>
-        <p:nvSpPr>
-          <p:cNvPr id="5" name="Notes Placeholder 4"/>
-          <p:cNvSpPr>
-            <a:spLocks noGrp="1"/>
-          </p:cNvSpPr>
-          <p:nvPr>
-            <p:ph type="body" sz="quarter" idx="3"/>
-          </p:nvPr>
-        </p:nvSpPr>
-        <p:spPr>
-          <a:xfrm>
-            <a:off x="685800" y="4400550"/>
-            <a:ext cx="5486400" cy="3600450"/>
-          </a:xfrm>
-          <a:prstGeom prst="rect">
-            <a:avLst/>
-          </a:prstGeom>
-        </p:spPr>
-        <p:txBody>
-          <a:bodyPr vert="horz" lIns="91440" tIns="45720" rIns="91440" bIns="45720" rtlCol="0"/>
-          <a:lstStyle/>
-          <a:p>
-            <a:pPr lvl="0"/>
-            <a:r>
-              <a:rPr lang="en-US"/>
-              <a:t>Click to edit Master text styles</a:t>
-            </a:r>
-          </a:p>
-          <a:p>
-            <a:pPr lvl="1"/>
-            <a:r>
-              <a:rPr lang="en-US"/>
-              <a:t>Second level</a:t>
-            </a:r>
-          </a:p>
-          <a:p>
-            <a:pPr lvl="2"/>
-            <a:r>
-              <a:rPr lang="en-US"/>
-              <a:t>Third level</a:t>
-            </a:r>
-          </a:p>
-          <a:p>
-            <a:pPr lvl="3"/>
-            <a:r>
-              <a:rPr lang="en-US"/>
-              <a:t>Fourth level</a:t>
-            </a:r>
-          </a:p>
-          <a:p>
-            <a:pPr lvl="4"/>
-            <a:r>
-              <a:rPr lang="en-US"/>
-              <a:t>Fifth level</a:t>
-            </a:r>
-          </a:p>
-        </p:txBody>
-      </p:sp>
-      <p:sp>
-        <p:nvSpPr>
-          <p:cNvPr id="6" name="Footer Placeholder 5"/>
-          <p:cNvSpPr>
-            <a:spLocks noGrp="1"/>
-          </p:cNvSpPr>
-          <p:nvPr>
-            <p:ph type="ftr" sz="quarter" idx="4"/>
-          </p:nvPr>
-        </p:nvSpPr>
-        <p:spPr>
-          <a:xfrm>
-            <a:off x="0" y="8685213"/>
-            <a:ext cx="2971800" cy="458787"/>
-          </a:xfrm>
-          <a:prstGeom prst="rect">
-            <a:avLst/>
-          </a:prstGeom>
-        </p:spPr>
-        <p:txBody>
-          <a:bodyPr vert="horz" lIns="91440" tIns="45720" rIns="91440" bIns="45720" rtlCol="0" anchor="b"/>
-          <a:lstStyle>
-            <a:lvl1pPr algn="l">
-              <a:defRPr sz="1200"/>
-            </a:lvl1pPr>
-          </a:lstStyle>
-          <a:p>
-            <a:endParaRPr lang="en-US"/>
-          </a:p>
-        </p:txBody>
-      </p:sp>
-      <p:sp>
-        <p:nvSpPr>
-          <p:cNvPr id="7" name="Slide Number Placeholder 6"/>
-          <p:cNvSpPr>
-            <a:spLocks noGrp="1"/>
-          </p:cNvSpPr>
-          <p:nvPr>
-            <p:ph type="sldNum" sz="quarter" idx="5"/>
-          </p:nvPr>
-        </p:nvSpPr>
-        <p:spPr>
-          <a:xfrm>
-            <a:off x="3884613" y="8685213"/>
-            <a:ext cx="2971800" cy="458787"/>
-          </a:xfrm>
-          <a:prstGeom prst="rect">
-            <a:avLst/>
-          </a:prstGeom>
-        </p:spPr>
-        <p:txBody>
-          <a:bodyPr vert="horz" lIns="91440" tIns="45720" rIns="91440" bIns="45720" rtlCol="0" anchor="b"/>
-          <a:lstStyle>
-            <a:lvl1pPr algn="r">
-              <a:defRPr sz="1200"/>
-            </a:lvl1pPr>
-          </a:lstStyle>
-          <a:p>
-            <a:fld id="{CE5E9CC1-C706-0F49-92D6-E571CC5EEA8F}" type="slidenum">
-              <a:rPr lang="en-US"/>
-              <a:t>‹#›</a:t>
-            </a:fld>
-            <a:endParaRPr lang="en-US"/>
-          </a:p>
-        </p:txBody>
-      </p:sp>
     </p:spTree>
     <p:extLst>
       <p:ext uri="{BB962C8B-B14F-4D97-AF65-F5344CB8AC3E}">
-        <p14:creationId xmlns:p14="http://schemas.microsoft.com/office/powerpoint/2010/main" val="1024086991"/>
+        <p14:creationId xmlns:p14="http://schemas.microsoft.com/office/powerpoint/2010/main" val="4197261579"/>
       </p:ext>
     </p:extLst>
   </p:cSld>
@@ -513,10 +294,6 @@
           <a:bodyPr/>
           <a:lstStyle/>
           <a:p>
-            <a:r>
-              <a:rPr lang="en-US" dirty="0"/>
-              <a:t/>
-            </a:r>
             <a:endParaRPr lang="en-US" dirty="0"/>
           </a:p>
         </p:txBody>
@@ -601,10 +378,6 @@
           <a:bodyPr/>
           <a:lstStyle/>
           <a:p>
-            <a:r>
-              <a:rPr lang="en-US" dirty="0"/>
-              <a:t/>
-            </a:r>
             <a:endParaRPr lang="en-US" dirty="0"/>
           </a:p>
         </p:txBody>
@@ -689,10 +462,6 @@
           <a:bodyPr/>
           <a:lstStyle/>
           <a:p>
-            <a:r>
-              <a:rPr lang="en-US" dirty="0"/>
-              <a:t/>
-            </a:r>
             <a:endParaRPr lang="en-US" dirty="0"/>
           </a:p>
         </p:txBody>
@@ -777,10 +546,6 @@
           <a:bodyPr/>
           <a:lstStyle/>
           <a:p>
-            <a:r>
-              <a:rPr lang="en-US" dirty="0"/>
-              <a:t/>
-            </a:r>
             <a:endParaRPr lang="en-US" dirty="0"/>
           </a:p>
         </p:txBody>
@@ -865,10 +630,6 @@
           <a:bodyPr/>
           <a:lstStyle/>
           <a:p>
-            <a:r>
-              <a:rPr lang="en-US" dirty="0"/>
-              <a:t/>
-            </a:r>
             <a:endParaRPr lang="en-US" dirty="0"/>
           </a:p>
         </p:txBody>
@@ -953,10 +714,6 @@
           <a:bodyPr/>
           <a:lstStyle/>
           <a:p>
-            <a:r>
-              <a:rPr lang="en-US" dirty="0"/>
-              <a:t/>
-            </a:r>
             <a:endParaRPr lang="en-US" dirty="0"/>
           </a:p>
         </p:txBody>
@@ -1041,10 +798,6 @@
           <a:bodyPr/>
           <a:lstStyle/>
           <a:p>
-            <a:r>
-              <a:rPr lang="en-US" dirty="0"/>
-              <a:t/>
-            </a:r>
             <a:endParaRPr lang="en-US" dirty="0"/>
           </a:p>
         </p:txBody>
@@ -1129,10 +882,6 @@
           <a:bodyPr/>
           <a:lstStyle/>
           <a:p>
-            <a:r>
-              <a:rPr lang="en-US" dirty="0"/>
-              <a:t/>
-            </a:r>
             <a:endParaRPr lang="en-US" dirty="0"/>
           </a:p>
         </p:txBody>
@@ -1217,10 +966,6 @@
           <a:bodyPr/>
           <a:lstStyle/>
           <a:p>
-            <a:r>
-              <a:rPr lang="en-US" dirty="0"/>
-              <a:t/>
-            </a:r>
             <a:endParaRPr lang="en-US" dirty="0"/>
           </a:p>
         </p:txBody>
@@ -1305,10 +1050,6 @@
           <a:bodyPr/>
           <a:lstStyle/>
           <a:p>
-            <a:r>
-              <a:rPr lang="en-US" dirty="0"/>
-              <a:t/>
-            </a:r>
             <a:endParaRPr lang="en-US" dirty="0"/>
           </a:p>
         </p:txBody>
@@ -1393,10 +1134,6 @@
           <a:bodyPr/>
           <a:lstStyle/>
           <a:p>
-            <a:r>
-              <a:rPr lang="en-US" dirty="0"/>
-              <a:t/>
-            </a:r>
             <a:endParaRPr lang="en-US" dirty="0"/>
           </a:p>
         </p:txBody>
@@ -1481,10 +1218,6 @@
           <a:bodyPr/>
           <a:lstStyle/>
           <a:p>
-            <a:r>
-              <a:rPr lang="en-US" dirty="0"/>
-              <a:t/>
-            </a:r>
             <a:endParaRPr lang="en-US" dirty="0"/>
           </a:p>
         </p:txBody>
@@ -1569,10 +1302,6 @@
           <a:bodyPr/>
           <a:lstStyle/>
           <a:p>
-            <a:r>
-              <a:rPr lang="en-US" dirty="0"/>
-              <a:t/>
-            </a:r>
             <a:endParaRPr lang="en-US" dirty="0"/>
           </a:p>
         </p:txBody>
@@ -1657,10 +1386,6 @@
           <a:bodyPr/>
           <a:lstStyle/>
           <a:p>
-            <a:r>
-              <a:rPr lang="en-US" dirty="0"/>
-              <a:t/>
-            </a:r>
             <a:endParaRPr lang="en-US" dirty="0"/>
           </a:p>
         </p:txBody>
@@ -1734,6 +1459,11 @@
 <file path=ppt/slideMasters/slideMaster1.xml><?xml version="1.0" encoding="utf-8"?>
 <p:sldMaster xmlns:a="http://schemas.openxmlformats.org/drawingml/2006/main" xmlns:r="http://schemas.openxmlformats.org/officeDocument/2006/relationships" xmlns:p="http://schemas.openxmlformats.org/presentationml/2006/main">
   <p:cSld>
+    <p:bg>
+      <p:bgRef idx="1001">
+        <a:schemeClr val="bg1"/>
+      </p:bgRef>
+    </p:bg>
     <p:spTree>
       <p:nvGrpSpPr>
         <p:cNvPr id="1" name=""/>
@@ -2016,6 +1746,7 @@
         <a:solidFill>
           <a:srgbClr val="0A0E0A"/>
         </a:solidFill>
+        <a:effectLst/>
       </p:bgPr>
     </p:bg>
     <p:spTree>
@@ -2078,7 +1809,7 @@
           <a:bodyPr wrap="square" lIns="0" tIns="0" rIns="0" bIns="0" rtlCol="0" anchor="ctr"/>
           <a:lstStyle/>
           <a:p>
-            <a:pPr algn="ctr" indent="0" marL="0">
+            <a:pPr marL="0" indent="0" algn="ctr">
               <a:buNone/>
             </a:pPr>
             <a:r>
@@ -2117,20 +1848,9 @@
           <a:bodyPr wrap="square" lIns="0" tIns="0" rIns="0" bIns="0" rtlCol="0" anchor="ctr"/>
           <a:lstStyle/>
           <a:p>
-            <a:pPr indent="0" marL="0">
-              <a:buNone/>
-            </a:pPr>
-            <a:r>
-              <a:rPr lang="en-US" sz="1200" dirty="0">
-                <a:solidFill>
-                  <a:srgbClr val="5FBF5F"/>
-                </a:solidFill>
-                <a:latin typeface="Consolas" pitchFamily="34" charset="0"/>
-                <a:ea typeface="Consolas" pitchFamily="34" charset="-122"/>
-                <a:cs typeface="Consolas" pitchFamily="34" charset="-120"/>
-              </a:rPr>
-              <a:t>$ initiating secure_session.exe</a:t>
-            </a:r>
+            <a:pPr marL="0" indent="0">
+              <a:buNone/>
+            </a:pPr>
             <a:endParaRPr lang="en-US" sz="1200" dirty="0"/>
           </a:p>
         </p:txBody>
@@ -2156,11 +1876,11 @@
           <a:bodyPr wrap="square" lIns="0" tIns="0" rIns="0" bIns="0" rtlCol="0" anchor="ctr"/>
           <a:lstStyle/>
           <a:p>
-            <a:pPr indent="0" marL="0">
-              <a:buNone/>
-            </a:pPr>
-            <a:r>
-              <a:rPr lang="en-US" sz="1200" b="1" spc="300" kern="0" dirty="0">
+            <a:pPr marL="0" indent="0">
+              <a:buNone/>
+            </a:pPr>
+            <a:r>
+              <a:rPr lang="en-US" sz="1200" b="1" kern="0" spc="300" dirty="0">
                 <a:solidFill>
                   <a:srgbClr val="E0B23C"/>
                 </a:solidFill>
@@ -2195,7 +1915,7 @@
           <a:bodyPr wrap="square" lIns="0" tIns="0" rIns="0" bIns="0" rtlCol="0" anchor="ctr"/>
           <a:lstStyle/>
           <a:p>
-            <a:pPr indent="0" marL="0">
+            <a:pPr marL="0" indent="0">
               <a:buNone/>
             </a:pPr>
             <a:r>
@@ -2234,7 +1954,7 @@
           <a:bodyPr wrap="square" lIns="0" tIns="0" rIns="0" bIns="0" rtlCol="0" anchor="ctr"/>
           <a:lstStyle/>
           <a:p>
-            <a:pPr indent="0" marL="0">
+            <a:pPr marL="0" indent="0">
               <a:buNone/>
             </a:pPr>
             <a:r>
@@ -2246,7 +1966,7 @@
                 <a:ea typeface="Consolas" pitchFamily="34" charset="-122"/>
                 <a:cs typeface="Consolas" pitchFamily="34" charset="-120"/>
               </a:rPr>
-              <a:t>&amp;gt; A Fake Login Page Backend System — Built and Explained Line by Line in Java</a:t>
+              <a:t> A Fake Login Page Backend System — Built and Explained Line by Line in Java</a:t>
             </a:r>
             <a:endParaRPr lang="en-US" sz="1500" dirty="0"/>
           </a:p>
@@ -2296,7 +2016,7 @@
           <a:bodyPr wrap="square" lIns="0" tIns="0" rIns="0" bIns="0" rtlCol="0" anchor="ctr"/>
           <a:lstStyle/>
           <a:p>
-            <a:pPr indent="0" marL="0">
+            <a:pPr marL="0" indent="0">
               <a:lnSpc>
                 <a:spcPts val="2100"/>
               </a:lnSpc>
@@ -2316,7 +2036,7 @@
             <a:endParaRPr lang="en-US" sz="1500" dirty="0"/>
           </a:p>
           <a:p>
-            <a:pPr indent="0" marL="0">
+            <a:pPr marL="0" indent="0">
               <a:lnSpc>
                 <a:spcPts val="2100"/>
               </a:lnSpc>
@@ -2336,7 +2056,7 @@
             <a:endParaRPr lang="en-US" sz="1500" dirty="0"/>
           </a:p>
           <a:p>
-            <a:pPr indent="0" marL="0">
+            <a:pPr marL="0" indent="0">
               <a:lnSpc>
                 <a:spcPts val="2100"/>
               </a:lnSpc>
@@ -2356,7 +2076,7 @@
             <a:endParaRPr lang="en-US" sz="1500" dirty="0"/>
           </a:p>
           <a:p>
-            <a:pPr indent="0" marL="0">
+            <a:pPr marL="0" indent="0">
               <a:lnSpc>
                 <a:spcPts val="2100"/>
               </a:lnSpc>
@@ -2393,6 +2113,7 @@
         <a:solidFill>
           <a:srgbClr val="0A0E0A"/>
         </a:solidFill>
+        <a:effectLst/>
       </p:bgPr>
     </p:bg>
     <p:spTree>
@@ -2430,7 +2151,7 @@
           <a:bodyPr wrap="square" lIns="0" tIns="0" rIns="0" bIns="0" rtlCol="0" anchor="ctr"/>
           <a:lstStyle/>
           <a:p>
-            <a:pPr indent="0" marL="0">
+            <a:pPr marL="0" indent="0">
               <a:buNone/>
             </a:pPr>
             <a:r>
@@ -2544,7 +2265,7 @@
           <a:bodyPr wrap="square" lIns="0" tIns="0" rIns="0" bIns="0" rtlCol="0" anchor="ctr"/>
           <a:lstStyle/>
           <a:p>
-            <a:pPr algn="ctr" indent="0" marL="0">
+            <a:pPr marL="0" indent="0" algn="ctr">
               <a:buNone/>
             </a:pPr>
             <a:r>
@@ -2583,7 +2304,7 @@
           <a:bodyPr wrap="square" lIns="0" tIns="0" rIns="0" bIns="0" rtlCol="0" anchor="ctr"/>
           <a:lstStyle/>
           <a:p>
-            <a:pPr indent="0" marL="0">
+            <a:pPr marL="0" indent="0">
               <a:buNone/>
             </a:pPr>
             <a:r>
@@ -2622,7 +2343,7 @@
           <a:bodyPr wrap="square" lIns="0" tIns="0" rIns="0" bIns="0" rtlCol="0" anchor="ctr"/>
           <a:lstStyle/>
           <a:p>
-            <a:pPr indent="0" marL="0">
+            <a:pPr marL="0" indent="0">
               <a:lnSpc>
                 <a:spcPts val="1500"/>
               </a:lnSpc>
@@ -2716,7 +2437,7 @@
           <a:bodyPr wrap="square" lIns="0" tIns="0" rIns="0" bIns="0" rtlCol="0" anchor="ctr"/>
           <a:lstStyle/>
           <a:p>
-            <a:pPr algn="ctr" indent="0" marL="0">
+            <a:pPr marL="0" indent="0" algn="ctr">
               <a:buNone/>
             </a:pPr>
             <a:r>
@@ -2755,7 +2476,7 @@
           <a:bodyPr wrap="square" lIns="0" tIns="0" rIns="0" bIns="0" rtlCol="0" anchor="ctr"/>
           <a:lstStyle/>
           <a:p>
-            <a:pPr indent="0" marL="0">
+            <a:pPr marL="0" indent="0">
               <a:buNone/>
             </a:pPr>
             <a:r>
@@ -2794,7 +2515,7 @@
           <a:bodyPr wrap="square" lIns="0" tIns="0" rIns="0" bIns="0" rtlCol="0" anchor="ctr"/>
           <a:lstStyle/>
           <a:p>
-            <a:pPr indent="0" marL="0">
+            <a:pPr marL="0" indent="0">
               <a:lnSpc>
                 <a:spcPts val="1500"/>
               </a:lnSpc>
@@ -2888,7 +2609,7 @@
           <a:bodyPr wrap="square" lIns="0" tIns="0" rIns="0" bIns="0" rtlCol="0" anchor="ctr"/>
           <a:lstStyle/>
           <a:p>
-            <a:pPr algn="ctr" indent="0" marL="0">
+            <a:pPr marL="0" indent="0" algn="ctr">
               <a:buNone/>
             </a:pPr>
             <a:r>
@@ -2927,7 +2648,7 @@
           <a:bodyPr wrap="square" lIns="0" tIns="0" rIns="0" bIns="0" rtlCol="0" anchor="ctr"/>
           <a:lstStyle/>
           <a:p>
-            <a:pPr indent="0" marL="0">
+            <a:pPr marL="0" indent="0">
               <a:buNone/>
             </a:pPr>
             <a:r>
@@ -2966,7 +2687,7 @@
           <a:bodyPr wrap="square" lIns="0" tIns="0" rIns="0" bIns="0" rtlCol="0" anchor="ctr"/>
           <a:lstStyle/>
           <a:p>
-            <a:pPr indent="0" marL="0">
+            <a:pPr marL="0" indent="0">
               <a:lnSpc>
                 <a:spcPts val="1500"/>
               </a:lnSpc>
@@ -3060,7 +2781,7 @@
           <a:bodyPr wrap="square" lIns="0" tIns="0" rIns="0" bIns="0" rtlCol="0" anchor="ctr"/>
           <a:lstStyle/>
           <a:p>
-            <a:pPr algn="ctr" indent="0" marL="0">
+            <a:pPr marL="0" indent="0" algn="ctr">
               <a:buNone/>
             </a:pPr>
             <a:r>
@@ -3099,7 +2820,7 @@
           <a:bodyPr wrap="square" lIns="0" tIns="0" rIns="0" bIns="0" rtlCol="0" anchor="ctr"/>
           <a:lstStyle/>
           <a:p>
-            <a:pPr indent="0" marL="0">
+            <a:pPr marL="0" indent="0">
               <a:buNone/>
             </a:pPr>
             <a:r>
@@ -3138,7 +2859,7 @@
           <a:bodyPr wrap="square" lIns="0" tIns="0" rIns="0" bIns="0" rtlCol="0" anchor="ctr"/>
           <a:lstStyle/>
           <a:p>
-            <a:pPr indent="0" marL="0">
+            <a:pPr marL="0" indent="0">
               <a:lnSpc>
                 <a:spcPts val="1500"/>
               </a:lnSpc>
@@ -3180,7 +2901,7 @@
           <a:bodyPr wrap="square" lIns="0" tIns="0" rIns="0" bIns="0" rtlCol="0" anchor="ctr"/>
           <a:lstStyle/>
           <a:p>
-            <a:pPr algn="l" indent="0" marL="0">
+            <a:pPr marL="0" indent="0" algn="l">
               <a:buNone/>
             </a:pPr>
             <a:r>
@@ -3219,7 +2940,7 @@
           <a:bodyPr wrap="square" lIns="0" tIns="0" rIns="0" bIns="0" rtlCol="0" anchor="ctr"/>
           <a:lstStyle/>
           <a:p>
-            <a:pPr algn="r" indent="0" marL="0">
+            <a:pPr marL="0" indent="0" algn="r">
               <a:buNone/>
             </a:pPr>
             <a:r>
@@ -3253,6 +2974,7 @@
         <a:solidFill>
           <a:srgbClr val="0A0E0A"/>
         </a:solidFill>
+        <a:effectLst/>
       </p:bgPr>
     </p:bg>
     <p:spTree>
@@ -3290,7 +3012,7 @@
           <a:bodyPr wrap="square" lIns="0" tIns="0" rIns="0" bIns="0" rtlCol="0" anchor="ctr"/>
           <a:lstStyle/>
           <a:p>
-            <a:pPr indent="0" marL="0">
+            <a:pPr marL="0" indent="0">
               <a:buNone/>
             </a:pPr>
             <a:r>
@@ -3329,7 +3051,7 @@
           <a:bodyPr wrap="square" lIns="0" tIns="0" rIns="0" bIns="0" rtlCol="0" anchor="ctr"/>
           <a:lstStyle/>
           <a:p>
-            <a:pPr indent="0" marL="0">
+            <a:pPr marL="0" indent="0">
               <a:buNone/>
             </a:pPr>
             <a:r>
@@ -3418,20 +3140,9 @@
           <a:bodyPr wrap="square" lIns="0" tIns="0" rIns="0" bIns="0" rtlCol="0" anchor="ctr"/>
           <a:lstStyle/>
           <a:p>
-            <a:pPr indent="0" marL="0">
-              <a:buNone/>
-            </a:pPr>
-            <a:r>
-              <a:rPr lang="en-US" sz="1600" b="1" dirty="0">
-                <a:solidFill>
-                  <a:srgbClr val="E0B23C"/>
-                </a:solidFill>
-                <a:latin typeface="Consolas" pitchFamily="34" charset="0"/>
-                <a:ea typeface="Consolas" pitchFamily="34" charset="-122"/>
-                <a:cs typeface="Consolas" pitchFamily="34" charset="-120"/>
-              </a:rPr>
-              <a:t>&amp;gt;</a:t>
-            </a:r>
+            <a:pPr marL="0" indent="0">
+              <a:buNone/>
+            </a:pPr>
             <a:endParaRPr lang="en-US" sz="1600" dirty="0"/>
           </a:p>
         </p:txBody>
@@ -3457,7 +3168,7 @@
           <a:bodyPr wrap="square" lIns="0" tIns="0" rIns="0" bIns="0" rtlCol="0" anchor="ctr"/>
           <a:lstStyle/>
           <a:p>
-            <a:pPr indent="0" marL="0">
+            <a:pPr marL="0" indent="0">
               <a:buNone/>
             </a:pPr>
             <a:r>
@@ -3496,7 +3207,7 @@
           <a:bodyPr wrap="square" lIns="0" tIns="0" rIns="0" bIns="0" rtlCol="0" anchor="ctr"/>
           <a:lstStyle/>
           <a:p>
-            <a:pPr indent="0" marL="0">
+            <a:pPr marL="0" indent="0">
               <a:buNone/>
             </a:pPr>
             <a:r>
@@ -3562,20 +3273,9 @@
           <a:bodyPr wrap="square" lIns="0" tIns="0" rIns="0" bIns="0" rtlCol="0" anchor="ctr"/>
           <a:lstStyle/>
           <a:p>
-            <a:pPr indent="0" marL="0">
-              <a:buNone/>
-            </a:pPr>
-            <a:r>
-              <a:rPr lang="en-US" sz="1600" b="1" dirty="0">
-                <a:solidFill>
-                  <a:srgbClr val="E0B23C"/>
-                </a:solidFill>
-                <a:latin typeface="Consolas" pitchFamily="34" charset="0"/>
-                <a:ea typeface="Consolas" pitchFamily="34" charset="-122"/>
-                <a:cs typeface="Consolas" pitchFamily="34" charset="-120"/>
-              </a:rPr>
-              <a:t>&amp;gt;</a:t>
-            </a:r>
+            <a:pPr marL="0" indent="0">
+              <a:buNone/>
+            </a:pPr>
             <a:endParaRPr lang="en-US" sz="1600" dirty="0"/>
           </a:p>
         </p:txBody>
@@ -3601,7 +3301,7 @@
           <a:bodyPr wrap="square" lIns="0" tIns="0" rIns="0" bIns="0" rtlCol="0" anchor="ctr"/>
           <a:lstStyle/>
           <a:p>
-            <a:pPr indent="0" marL="0">
+            <a:pPr marL="0" indent="0">
               <a:buNone/>
             </a:pPr>
             <a:r>
@@ -3640,7 +3340,7 @@
           <a:bodyPr wrap="square" lIns="0" tIns="0" rIns="0" bIns="0" rtlCol="0" anchor="ctr"/>
           <a:lstStyle/>
           <a:p>
-            <a:pPr indent="0" marL="0">
+            <a:pPr marL="0" indent="0">
               <a:buNone/>
             </a:pPr>
             <a:r>
@@ -3706,20 +3406,9 @@
           <a:bodyPr wrap="square" lIns="0" tIns="0" rIns="0" bIns="0" rtlCol="0" anchor="ctr"/>
           <a:lstStyle/>
           <a:p>
-            <a:pPr indent="0" marL="0">
-              <a:buNone/>
-            </a:pPr>
-            <a:r>
-              <a:rPr lang="en-US" sz="1600" b="1" dirty="0">
-                <a:solidFill>
-                  <a:srgbClr val="E0B23C"/>
-                </a:solidFill>
-                <a:latin typeface="Consolas" pitchFamily="34" charset="0"/>
-                <a:ea typeface="Consolas" pitchFamily="34" charset="-122"/>
-                <a:cs typeface="Consolas" pitchFamily="34" charset="-120"/>
-              </a:rPr>
-              <a:t>&amp;gt;</a:t>
-            </a:r>
+            <a:pPr marL="0" indent="0">
+              <a:buNone/>
+            </a:pPr>
             <a:endParaRPr lang="en-US" sz="1600" dirty="0"/>
           </a:p>
         </p:txBody>
@@ -3745,7 +3434,7 @@
           <a:bodyPr wrap="square" lIns="0" tIns="0" rIns="0" bIns="0" rtlCol="0" anchor="ctr"/>
           <a:lstStyle/>
           <a:p>
-            <a:pPr indent="0" marL="0">
+            <a:pPr marL="0" indent="0">
               <a:buNone/>
             </a:pPr>
             <a:r>
@@ -3784,7 +3473,7 @@
           <a:bodyPr wrap="square" lIns="0" tIns="0" rIns="0" bIns="0" rtlCol="0" anchor="ctr"/>
           <a:lstStyle/>
           <a:p>
-            <a:pPr indent="0" marL="0">
+            <a:pPr marL="0" indent="0">
               <a:buNone/>
             </a:pPr>
             <a:r>
@@ -3850,20 +3539,9 @@
           <a:bodyPr wrap="square" lIns="0" tIns="0" rIns="0" bIns="0" rtlCol="0" anchor="ctr"/>
           <a:lstStyle/>
           <a:p>
-            <a:pPr indent="0" marL="0">
-              <a:buNone/>
-            </a:pPr>
-            <a:r>
-              <a:rPr lang="en-US" sz="1600" b="1" dirty="0">
-                <a:solidFill>
-                  <a:srgbClr val="E0B23C"/>
-                </a:solidFill>
-                <a:latin typeface="Consolas" pitchFamily="34" charset="0"/>
-                <a:ea typeface="Consolas" pitchFamily="34" charset="-122"/>
-                <a:cs typeface="Consolas" pitchFamily="34" charset="-120"/>
-              </a:rPr>
-              <a:t>&amp;gt;</a:t>
-            </a:r>
+            <a:pPr marL="0" indent="0">
+              <a:buNone/>
+            </a:pPr>
             <a:endParaRPr lang="en-US" sz="1600" dirty="0"/>
           </a:p>
         </p:txBody>
@@ -3889,7 +3567,7 @@
           <a:bodyPr wrap="square" lIns="0" tIns="0" rIns="0" bIns="0" rtlCol="0" anchor="ctr"/>
           <a:lstStyle/>
           <a:p>
-            <a:pPr indent="0" marL="0">
+            <a:pPr marL="0" indent="0">
               <a:buNone/>
             </a:pPr>
             <a:r>
@@ -3928,7 +3606,7 @@
           <a:bodyPr wrap="square" lIns="0" tIns="0" rIns="0" bIns="0" rtlCol="0" anchor="ctr"/>
           <a:lstStyle/>
           <a:p>
-            <a:pPr indent="0" marL="0">
+            <a:pPr marL="0" indent="0">
               <a:buNone/>
             </a:pPr>
             <a:r>
@@ -3994,20 +3672,9 @@
           <a:bodyPr wrap="square" lIns="0" tIns="0" rIns="0" bIns="0" rtlCol="0" anchor="ctr"/>
           <a:lstStyle/>
           <a:p>
-            <a:pPr indent="0" marL="0">
-              <a:buNone/>
-            </a:pPr>
-            <a:r>
-              <a:rPr lang="en-US" sz="1600" b="1" dirty="0">
-                <a:solidFill>
-                  <a:srgbClr val="E0B23C"/>
-                </a:solidFill>
-                <a:latin typeface="Consolas" pitchFamily="34" charset="0"/>
-                <a:ea typeface="Consolas" pitchFamily="34" charset="-122"/>
-                <a:cs typeface="Consolas" pitchFamily="34" charset="-120"/>
-              </a:rPr>
-              <a:t>&amp;gt;</a:t>
-            </a:r>
+            <a:pPr marL="0" indent="0">
+              <a:buNone/>
+            </a:pPr>
             <a:endParaRPr lang="en-US" sz="1600" dirty="0"/>
           </a:p>
         </p:txBody>
@@ -4033,7 +3700,7 @@
           <a:bodyPr wrap="square" lIns="0" tIns="0" rIns="0" bIns="0" rtlCol="0" anchor="ctr"/>
           <a:lstStyle/>
           <a:p>
-            <a:pPr indent="0" marL="0">
+            <a:pPr marL="0" indent="0">
               <a:buNone/>
             </a:pPr>
             <a:r>
@@ -4072,7 +3739,7 @@
           <a:bodyPr wrap="square" lIns="0" tIns="0" rIns="0" bIns="0" rtlCol="0" anchor="ctr"/>
           <a:lstStyle/>
           <a:p>
-            <a:pPr indent="0" marL="0">
+            <a:pPr marL="0" indent="0">
               <a:buNone/>
             </a:pPr>
             <a:r>
@@ -4111,7 +3778,7 @@
           <a:bodyPr wrap="square" lIns="0" tIns="0" rIns="0" bIns="0" rtlCol="0" anchor="ctr"/>
           <a:lstStyle/>
           <a:p>
-            <a:pPr algn="l" indent="0" marL="0">
+            <a:pPr marL="0" indent="0" algn="l">
               <a:buNone/>
             </a:pPr>
             <a:r>
@@ -4150,7 +3817,7 @@
           <a:bodyPr wrap="square" lIns="0" tIns="0" rIns="0" bIns="0" rtlCol="0" anchor="ctr"/>
           <a:lstStyle/>
           <a:p>
-            <a:pPr algn="r" indent="0" marL="0">
+            <a:pPr marL="0" indent="0" algn="r">
               <a:buNone/>
             </a:pPr>
             <a:r>
@@ -4184,6 +3851,7 @@
         <a:solidFill>
           <a:srgbClr val="0A0E0A"/>
         </a:solidFill>
+        <a:effectLst/>
       </p:bgPr>
     </p:bg>
     <p:spTree>
@@ -4221,7 +3889,7 @@
           <a:bodyPr wrap="square" lIns="0" tIns="0" rIns="0" bIns="0" rtlCol="0" anchor="ctr"/>
           <a:lstStyle/>
           <a:p>
-            <a:pPr indent="0" marL="0">
+            <a:pPr marL="0" indent="0">
               <a:buNone/>
             </a:pPr>
             <a:r>
@@ -4310,7 +3978,7 @@
           <a:bodyPr wrap="square" lIns="0" tIns="0" rIns="0" bIns="0" rtlCol="0" anchor="ctr"/>
           <a:lstStyle/>
           <a:p>
-            <a:pPr indent="0" marL="0">
+            <a:pPr marL="0" indent="0">
               <a:buNone/>
             </a:pPr>
             <a:r>
@@ -4322,7 +3990,7 @@
                 <a:ea typeface="Consolas" pitchFamily="34" charset="-122"/>
                 <a:cs typeface="Consolas" pitchFamily="34" charset="-120"/>
               </a:rPr>
-              <a:t>&amp;gt; ACHIEVED OUTCOMES</a:t>
+              <a:t> ACHIEVED OUTCOMES</a:t>
             </a:r>
             <a:endParaRPr lang="en-US" sz="1400" dirty="0"/>
           </a:p>
@@ -4373,7 +4041,7 @@
             <a:endParaRPr lang="en-US" sz="1150" dirty="0"/>
           </a:p>
           <a:p>
-            <a:pPr indent="0" marL="0">
+            <a:pPr marL="0" indent="0">
               <a:lnSpc>
                 <a:spcPts val="1600"/>
               </a:lnSpc>
@@ -4396,7 +4064,7 @@
             <a:endParaRPr lang="en-US" sz="1150" dirty="0"/>
           </a:p>
           <a:p>
-            <a:pPr indent="0" marL="0">
+            <a:pPr marL="0" indent="0">
               <a:lnSpc>
                 <a:spcPts val="1600"/>
               </a:lnSpc>
@@ -4419,7 +4087,7 @@
             <a:endParaRPr lang="en-US" sz="1150" dirty="0"/>
           </a:p>
           <a:p>
-            <a:pPr indent="0" marL="0">
+            <a:pPr marL="0" indent="0">
               <a:lnSpc>
                 <a:spcPts val="1600"/>
               </a:lnSpc>
@@ -4442,7 +4110,7 @@
             <a:endParaRPr lang="en-US" sz="1150" dirty="0"/>
           </a:p>
           <a:p>
-            <a:pPr indent="0" marL="0">
+            <a:pPr marL="0" indent="0">
               <a:lnSpc>
                 <a:spcPts val="1600"/>
               </a:lnSpc>
@@ -4465,7 +4133,7 @@
             <a:endParaRPr lang="en-US" sz="1150" dirty="0"/>
           </a:p>
           <a:p>
-            <a:pPr indent="0" marL="0">
+            <a:pPr marL="0" indent="0">
               <a:lnSpc>
                 <a:spcPts val="1600"/>
               </a:lnSpc>
@@ -4534,7 +4202,7 @@
           <a:bodyPr wrap="square" lIns="0" tIns="0" rIns="0" bIns="0" rtlCol="0" anchor="ctr"/>
           <a:lstStyle/>
           <a:p>
-            <a:pPr indent="0" marL="0">
+            <a:pPr marL="0" indent="0">
               <a:buNone/>
             </a:pPr>
             <a:r>
@@ -4546,7 +4214,7 @@
                 <a:ea typeface="Consolas" pitchFamily="34" charset="-122"/>
                 <a:cs typeface="Consolas" pitchFamily="34" charset="-120"/>
               </a:rPr>
-              <a:t>&amp;gt; DELIVERABLES</a:t>
+              <a:t> DELIVERABLES</a:t>
             </a:r>
             <a:endParaRPr lang="en-US" sz="1400" dirty="0"/>
           </a:p>
@@ -4597,7 +4265,7 @@
             <a:endParaRPr lang="en-US" sz="1200" dirty="0"/>
           </a:p>
           <a:p>
-            <a:pPr indent="0" marL="0">
+            <a:pPr marL="0" indent="0">
               <a:lnSpc>
                 <a:spcPts val="1700"/>
               </a:lnSpc>
@@ -4620,7 +4288,7 @@
             <a:endParaRPr lang="en-US" sz="1200" dirty="0"/>
           </a:p>
           <a:p>
-            <a:pPr indent="0" marL="0">
+            <a:pPr marL="0" indent="0">
               <a:lnSpc>
                 <a:spcPts val="1700"/>
               </a:lnSpc>
@@ -4643,7 +4311,7 @@
             <a:endParaRPr lang="en-US" sz="1200" dirty="0"/>
           </a:p>
           <a:p>
-            <a:pPr indent="0" marL="0">
+            <a:pPr marL="0" indent="0">
               <a:lnSpc>
                 <a:spcPts val="1700"/>
               </a:lnSpc>
@@ -4666,7 +4334,7 @@
             <a:endParaRPr lang="en-US" sz="1200" dirty="0"/>
           </a:p>
           <a:p>
-            <a:pPr indent="0" marL="0">
+            <a:pPr marL="0" indent="0">
               <a:lnSpc>
                 <a:spcPts val="1700"/>
               </a:lnSpc>
@@ -4708,7 +4376,7 @@
           <a:bodyPr wrap="square" lIns="0" tIns="0" rIns="0" bIns="0" rtlCol="0" anchor="ctr"/>
           <a:lstStyle/>
           <a:p>
-            <a:pPr algn="l" indent="0" marL="0">
+            <a:pPr marL="0" indent="0" algn="l">
               <a:buNone/>
             </a:pPr>
             <a:r>
@@ -4747,7 +4415,7 @@
           <a:bodyPr wrap="square" lIns="0" tIns="0" rIns="0" bIns="0" rtlCol="0" anchor="ctr"/>
           <a:lstStyle/>
           <a:p>
-            <a:pPr algn="r" indent="0" marL="0">
+            <a:pPr marL="0" indent="0" algn="r">
               <a:buNone/>
             </a:pPr>
             <a:r>
@@ -4781,6 +4449,7 @@
         <a:solidFill>
           <a:srgbClr val="0A0E0A"/>
         </a:solidFill>
+        <a:effectLst/>
       </p:bgPr>
     </p:bg>
     <p:spTree>
@@ -4818,7 +4487,7 @@
           <a:bodyPr wrap="square" lIns="0" tIns="0" rIns="0" bIns="0" rtlCol="0" anchor="ctr"/>
           <a:lstStyle/>
           <a:p>
-            <a:pPr indent="0" marL="0">
+            <a:pPr marL="0" indent="0">
               <a:buNone/>
             </a:pPr>
             <a:r>
@@ -4880,7 +4549,7 @@
           <a:bodyPr wrap="square" lIns="0" tIns="0" rIns="0" bIns="0" rtlCol="0" anchor="ctr"/>
           <a:lstStyle/>
           <a:p>
-            <a:pPr indent="0" marL="0">
+            <a:pPr marL="0" indent="0">
               <a:buNone/>
             </a:pPr>
             <a:r>
@@ -4892,7 +4561,7 @@
                 <a:ea typeface="Consolas" pitchFamily="34" charset="-122"/>
                 <a:cs typeface="Consolas" pitchFamily="34" charset="-120"/>
               </a:rPr>
-              <a:t>&amp;gt; CURRENT LIMITATIONS</a:t>
+              <a:t> CURRENT LIMITATIONS</a:t>
             </a:r>
             <a:endParaRPr lang="en-US" sz="1400" dirty="0"/>
           </a:p>
@@ -4943,7 +4612,7 @@
             <a:endParaRPr lang="en-US" sz="1250" dirty="0"/>
           </a:p>
           <a:p>
-            <a:pPr indent="0" marL="0">
+            <a:pPr marL="0" indent="0">
               <a:lnSpc>
                 <a:spcPts val="1800"/>
               </a:lnSpc>
@@ -4966,7 +4635,7 @@
             <a:endParaRPr lang="en-US" sz="1250" dirty="0"/>
           </a:p>
           <a:p>
-            <a:pPr indent="0" marL="0">
+            <a:pPr marL="0" indent="0">
               <a:lnSpc>
                 <a:spcPts val="1800"/>
               </a:lnSpc>
@@ -4989,7 +4658,7 @@
             <a:endParaRPr lang="en-US" sz="1250" dirty="0"/>
           </a:p>
           <a:p>
-            <a:pPr indent="0" marL="0">
+            <a:pPr marL="0" indent="0">
               <a:lnSpc>
                 <a:spcPts val="1800"/>
               </a:lnSpc>
@@ -5031,7 +4700,7 @@
           <a:bodyPr wrap="square" lIns="0" tIns="0" rIns="0" bIns="0" rtlCol="0" anchor="ctr"/>
           <a:lstStyle/>
           <a:p>
-            <a:pPr indent="0" marL="0">
+            <a:pPr marL="0" indent="0">
               <a:buNone/>
             </a:pPr>
             <a:r>
@@ -5043,7 +4712,7 @@
                 <a:ea typeface="Consolas" pitchFamily="34" charset="-122"/>
                 <a:cs typeface="Consolas" pitchFamily="34" charset="-120"/>
               </a:rPr>
-              <a:t>&amp;gt; FUTURE WORK</a:t>
+              <a:t> FUTURE WORK</a:t>
             </a:r>
             <a:endParaRPr lang="en-US" sz="1400" dirty="0"/>
           </a:p>
@@ -5094,7 +4763,7 @@
             <a:endParaRPr lang="en-US" sz="1250" dirty="0"/>
           </a:p>
           <a:p>
-            <a:pPr indent="0" marL="0">
+            <a:pPr marL="0" indent="0">
               <a:lnSpc>
                 <a:spcPts val="1800"/>
               </a:lnSpc>
@@ -5117,7 +4786,7 @@
             <a:endParaRPr lang="en-US" sz="1250" dirty="0"/>
           </a:p>
           <a:p>
-            <a:pPr indent="0" marL="0">
+            <a:pPr marL="0" indent="0">
               <a:lnSpc>
                 <a:spcPts val="1800"/>
               </a:lnSpc>
@@ -5140,7 +4809,7 @@
             <a:endParaRPr lang="en-US" sz="1250" dirty="0"/>
           </a:p>
           <a:p>
-            <a:pPr indent="0" marL="0">
+            <a:pPr marL="0" indent="0">
               <a:lnSpc>
                 <a:spcPts val="1800"/>
               </a:lnSpc>
@@ -5182,7 +4851,7 @@
           <a:bodyPr wrap="square" lIns="0" tIns="0" rIns="0" bIns="0" rtlCol="0" anchor="ctr"/>
           <a:lstStyle/>
           <a:p>
-            <a:pPr algn="l" indent="0" marL="0">
+            <a:pPr marL="0" indent="0" algn="l">
               <a:buNone/>
             </a:pPr>
             <a:r>
@@ -5221,7 +4890,7 @@
           <a:bodyPr wrap="square" lIns="0" tIns="0" rIns="0" bIns="0" rtlCol="0" anchor="ctr"/>
           <a:lstStyle/>
           <a:p>
-            <a:pPr algn="r" indent="0" marL="0">
+            <a:pPr marL="0" indent="0" algn="r">
               <a:buNone/>
             </a:pPr>
             <a:r>
@@ -5255,6 +4924,7 @@
         <a:solidFill>
           <a:srgbClr val="0A0E0A"/>
         </a:solidFill>
+        <a:effectLst/>
       </p:bgPr>
     </p:bg>
     <p:spTree>
@@ -5317,7 +4987,7 @@
           <a:bodyPr wrap="square" lIns="0" tIns="0" rIns="0" bIns="0" rtlCol="0" anchor="ctr"/>
           <a:lstStyle/>
           <a:p>
-            <a:pPr algn="ctr" indent="0" marL="0">
+            <a:pPr marL="0" indent="0" algn="ctr">
               <a:buNone/>
             </a:pPr>
             <a:r>
@@ -5356,7 +5026,7 @@
           <a:bodyPr wrap="square" lIns="0" tIns="0" rIns="0" bIns="0" rtlCol="0" anchor="ctr"/>
           <a:lstStyle/>
           <a:p>
-            <a:pPr algn="ctr" indent="0" marL="0">
+            <a:pPr marL="0" indent="0" algn="ctr">
               <a:buNone/>
             </a:pPr>
             <a:r>
@@ -5368,7 +5038,7 @@
                 <a:ea typeface="Consolas" pitchFamily="34" charset="-122"/>
                 <a:cs typeface="Consolas" pitchFamily="34" charset="-120"/>
               </a:rPr>
-              <a:t>&amp;gt; Conclusion</a:t>
+              <a:t>Conclusion</a:t>
             </a:r>
             <a:endParaRPr lang="en-US" sz="3000" dirty="0"/>
           </a:p>
@@ -5395,7 +5065,7 @@
           <a:bodyPr wrap="square" lIns="0" tIns="0" rIns="0" bIns="0" rtlCol="0" anchor="ctr"/>
           <a:lstStyle/>
           <a:p>
-            <a:pPr algn="ctr" indent="0" marL="0">
+            <a:pPr marL="0" indent="0" algn="ctr">
               <a:lnSpc>
                 <a:spcPts val="2000"/>
               </a:lnSpc>
@@ -5460,7 +5130,7 @@
           <a:bodyPr wrap="square" lIns="0" tIns="0" rIns="0" bIns="0" rtlCol="0" anchor="ctr"/>
           <a:lstStyle/>
           <a:p>
-            <a:pPr algn="ctr" indent="0" marL="0">
+            <a:pPr marL="0" indent="0" algn="ctr">
               <a:buNone/>
             </a:pPr>
             <a:r>
@@ -5499,7 +5169,7 @@
           <a:bodyPr wrap="square" lIns="0" tIns="0" rIns="0" bIns="0" rtlCol="0" anchor="ctr"/>
           <a:lstStyle/>
           <a:p>
-            <a:pPr algn="ctr" indent="0" marL="0">
+            <a:pPr marL="0" indent="0" algn="ctr">
               <a:buNone/>
             </a:pPr>
             <a:r>
@@ -5511,9 +5181,8 @@
                 <a:ea typeface="Consolas" pitchFamily="34" charset="-122"/>
                 <a:cs typeface="Consolas" pitchFamily="34" charset="-120"/>
               </a:rPr>
-              <a:t>&amp;gt; Questions?_</a:t>
-            </a:r>
-            <a:endParaRPr lang="en-US" sz="1300" dirty="0"/>
+              <a:t>Questions?</a:t>
+            </a:r>
           </a:p>
         </p:txBody>
       </p:sp>
@@ -5533,6 +5202,7 @@
         <a:solidFill>
           <a:srgbClr val="0A0E0A"/>
         </a:solidFill>
+        <a:effectLst/>
       </p:bgPr>
     </p:bg>
     <p:spTree>
@@ -5570,7 +5240,7 @@
           <a:bodyPr wrap="square" lIns="0" tIns="0" rIns="0" bIns="0" rtlCol="0" anchor="ctr"/>
           <a:lstStyle/>
           <a:p>
-            <a:pPr indent="0" marL="0">
+            <a:pPr marL="0" indent="0">
               <a:buNone/>
             </a:pPr>
             <a:r>
@@ -5609,7 +5279,7 @@
           <a:bodyPr wrap="square" lIns="0" tIns="0" rIns="0" bIns="0" rtlCol="0" anchor="ctr"/>
           <a:lstStyle/>
           <a:p>
-            <a:pPr indent="0" marL="0">
+            <a:pPr marL="0" indent="0">
               <a:buNone/>
             </a:pPr>
             <a:r>
@@ -5698,7 +5368,7 @@
           <a:bodyPr wrap="square" lIns="0" tIns="0" rIns="0" bIns="0" rtlCol="0" anchor="ctr"/>
           <a:lstStyle/>
           <a:p>
-            <a:pPr algn="ctr" indent="0" marL="0">
+            <a:pPr marL="0" indent="0" algn="ctr">
               <a:buNone/>
             </a:pPr>
             <a:r>
@@ -5737,7 +5407,7 @@
           <a:bodyPr wrap="square" lIns="0" tIns="0" rIns="0" bIns="0" rtlCol="0" anchor="ctr"/>
           <a:lstStyle/>
           <a:p>
-            <a:pPr algn="ctr" indent="0" marL="0">
+            <a:pPr marL="0" indent="0" algn="ctr">
               <a:buNone/>
             </a:pPr>
             <a:r>
@@ -5803,7 +5473,7 @@
           <a:bodyPr wrap="square" lIns="0" tIns="0" rIns="0" bIns="0" rtlCol="0" anchor="ctr"/>
           <a:lstStyle/>
           <a:p>
-            <a:pPr algn="ctr" indent="0" marL="0">
+            <a:pPr marL="0" indent="0" algn="ctr">
               <a:buNone/>
             </a:pPr>
             <a:r>
@@ -5842,7 +5512,7 @@
           <a:bodyPr wrap="square" lIns="0" tIns="0" rIns="0" bIns="0" rtlCol="0" anchor="ctr"/>
           <a:lstStyle/>
           <a:p>
-            <a:pPr algn="ctr" indent="0" marL="0">
+            <a:pPr marL="0" indent="0" algn="ctr">
               <a:buNone/>
             </a:pPr>
             <a:r>
@@ -5908,7 +5578,7 @@
           <a:bodyPr wrap="square" lIns="0" tIns="0" rIns="0" bIns="0" rtlCol="0" anchor="ctr"/>
           <a:lstStyle/>
           <a:p>
-            <a:pPr algn="ctr" indent="0" marL="0">
+            <a:pPr marL="0" indent="0" algn="ctr">
               <a:buNone/>
             </a:pPr>
             <a:r>
@@ -5947,7 +5617,7 @@
           <a:bodyPr wrap="square" lIns="0" tIns="0" rIns="0" bIns="0" rtlCol="0" anchor="ctr"/>
           <a:lstStyle/>
           <a:p>
-            <a:pPr algn="ctr" indent="0" marL="0">
+            <a:pPr marL="0" indent="0" algn="ctr">
               <a:buNone/>
             </a:pPr>
             <a:r>
@@ -6013,7 +5683,7 @@
           <a:bodyPr wrap="square" lIns="0" tIns="0" rIns="0" bIns="0" rtlCol="0" anchor="ctr"/>
           <a:lstStyle/>
           <a:p>
-            <a:pPr indent="0" marL="0">
+            <a:pPr marL="0" indent="0">
               <a:buNone/>
             </a:pPr>
             <a:r>
@@ -6025,7 +5695,7 @@
                 <a:ea typeface="Consolas" pitchFamily="34" charset="-122"/>
                 <a:cs typeface="Consolas" pitchFamily="34" charset="-120"/>
               </a:rPr>
-              <a:t>&amp;gt; THIS PROJECT'S CORE IDEA:</a:t>
+              <a:t>THIS PROJECT'S CORE IDEA:</a:t>
             </a:r>
             <a:endParaRPr lang="en-US" sz="1150" dirty="0"/>
           </a:p>
@@ -6052,7 +5722,7 @@
           <a:bodyPr wrap="square" lIns="0" tIns="0" rIns="0" bIns="0" rtlCol="0" anchor="ctr"/>
           <a:lstStyle/>
           <a:p>
-            <a:pPr indent="0" marL="0">
+            <a:pPr marL="0" indent="0">
               <a:lnSpc>
                 <a:spcPts val="2000"/>
               </a:lnSpc>
@@ -6094,7 +5764,7 @@
           <a:bodyPr wrap="square" lIns="0" tIns="0" rIns="0" bIns="0" rtlCol="0" anchor="ctr"/>
           <a:lstStyle/>
           <a:p>
-            <a:pPr algn="l" indent="0" marL="0">
+            <a:pPr marL="0" indent="0" algn="l">
               <a:buNone/>
             </a:pPr>
             <a:r>
@@ -6133,7 +5803,7 @@
           <a:bodyPr wrap="square" lIns="0" tIns="0" rIns="0" bIns="0" rtlCol="0" anchor="ctr"/>
           <a:lstStyle/>
           <a:p>
-            <a:pPr algn="r" indent="0" marL="0">
+            <a:pPr marL="0" indent="0" algn="r">
               <a:buNone/>
             </a:pPr>
             <a:r>
@@ -6167,6 +5837,7 @@
         <a:solidFill>
           <a:srgbClr val="0A0E0A"/>
         </a:solidFill>
+        <a:effectLst/>
       </p:bgPr>
     </p:bg>
     <p:spTree>
@@ -6204,7 +5875,7 @@
           <a:bodyPr wrap="square" lIns="0" tIns="0" rIns="0" bIns="0" rtlCol="0" anchor="ctr"/>
           <a:lstStyle/>
           <a:p>
-            <a:pPr indent="0" marL="0">
+            <a:pPr marL="0" indent="0">
               <a:buNone/>
             </a:pPr>
             <a:r>
@@ -6266,7 +5937,7 @@
           <a:bodyPr wrap="square" lIns="0" tIns="0" rIns="0" bIns="0" rtlCol="0" anchor="ctr"/>
           <a:lstStyle/>
           <a:p>
-            <a:pPr indent="0" marL="0">
+            <a:pPr marL="0" indent="0">
               <a:lnSpc>
                 <a:spcPts val="2100"/>
               </a:lnSpc>
@@ -6335,7 +6006,7 @@
           <a:bodyPr wrap="square" lIns="0" tIns="0" rIns="0" bIns="0" rtlCol="0" anchor="ctr"/>
           <a:lstStyle/>
           <a:p>
-            <a:pPr algn="ctr" indent="0" marL="0">
+            <a:pPr marL="0" indent="0" algn="ctr">
               <a:buNone/>
             </a:pPr>
             <a:r>
@@ -6374,7 +6045,7 @@
           <a:bodyPr wrap="square" lIns="0" tIns="0" rIns="0" bIns="0" rtlCol="0" anchor="ctr"/>
           <a:lstStyle/>
           <a:p>
-            <a:pPr indent="0" marL="0">
+            <a:pPr marL="0" indent="0">
               <a:buNone/>
             </a:pPr>
             <a:r>
@@ -6440,7 +6111,7 @@
           <a:bodyPr wrap="square" lIns="0" tIns="0" rIns="0" bIns="0" rtlCol="0" anchor="ctr"/>
           <a:lstStyle/>
           <a:p>
-            <a:pPr algn="ctr" indent="0" marL="0">
+            <a:pPr marL="0" indent="0" algn="ctr">
               <a:buNone/>
             </a:pPr>
             <a:r>
@@ -6479,7 +6150,7 @@
           <a:bodyPr wrap="square" lIns="0" tIns="0" rIns="0" bIns="0" rtlCol="0" anchor="ctr"/>
           <a:lstStyle/>
           <a:p>
-            <a:pPr indent="0" marL="0">
+            <a:pPr marL="0" indent="0">
               <a:buNone/>
             </a:pPr>
             <a:r>
@@ -6545,7 +6216,7 @@
           <a:bodyPr wrap="square" lIns="0" tIns="0" rIns="0" bIns="0" rtlCol="0" anchor="ctr"/>
           <a:lstStyle/>
           <a:p>
-            <a:pPr algn="ctr" indent="0" marL="0">
+            <a:pPr marL="0" indent="0" algn="ctr">
               <a:buNone/>
             </a:pPr>
             <a:r>
@@ -6584,7 +6255,7 @@
           <a:bodyPr wrap="square" lIns="0" tIns="0" rIns="0" bIns="0" rtlCol="0" anchor="ctr"/>
           <a:lstStyle/>
           <a:p>
-            <a:pPr indent="0" marL="0">
+            <a:pPr marL="0" indent="0">
               <a:buNone/>
             </a:pPr>
             <a:r>
@@ -6650,7 +6321,7 @@
           <a:bodyPr wrap="square" lIns="0" tIns="0" rIns="0" bIns="0" rtlCol="0" anchor="ctr"/>
           <a:lstStyle/>
           <a:p>
-            <a:pPr algn="ctr" indent="0" marL="0">
+            <a:pPr marL="0" indent="0" algn="ctr">
               <a:buNone/>
             </a:pPr>
             <a:r>
@@ -6689,7 +6360,7 @@
           <a:bodyPr wrap="square" lIns="0" tIns="0" rIns="0" bIns="0" rtlCol="0" anchor="ctr"/>
           <a:lstStyle/>
           <a:p>
-            <a:pPr indent="0" marL="0">
+            <a:pPr marL="0" indent="0">
               <a:buNone/>
             </a:pPr>
             <a:r>
@@ -6755,7 +6426,7 @@
           <a:bodyPr wrap="square" lIns="0" tIns="0" rIns="0" bIns="0" rtlCol="0" anchor="ctr"/>
           <a:lstStyle/>
           <a:p>
-            <a:pPr algn="ctr" indent="0" marL="0">
+            <a:pPr marL="0" indent="0" algn="ctr">
               <a:buNone/>
             </a:pPr>
             <a:r>
@@ -6794,7 +6465,7 @@
           <a:bodyPr wrap="square" lIns="0" tIns="0" rIns="0" bIns="0" rtlCol="0" anchor="ctr"/>
           <a:lstStyle/>
           <a:p>
-            <a:pPr indent="0" marL="0">
+            <a:pPr marL="0" indent="0">
               <a:buNone/>
             </a:pPr>
             <a:r>
@@ -6833,7 +6504,7 @@
           <a:bodyPr wrap="square" lIns="0" tIns="0" rIns="0" bIns="0" rtlCol="0" anchor="ctr"/>
           <a:lstStyle/>
           <a:p>
-            <a:pPr algn="l" indent="0" marL="0">
+            <a:pPr marL="0" indent="0" algn="l">
               <a:buNone/>
             </a:pPr>
             <a:r>
@@ -6872,7 +6543,7 @@
           <a:bodyPr wrap="square" lIns="0" tIns="0" rIns="0" bIns="0" rtlCol="0" anchor="ctr"/>
           <a:lstStyle/>
           <a:p>
-            <a:pPr algn="r" indent="0" marL="0">
+            <a:pPr marL="0" indent="0" algn="r">
               <a:buNone/>
             </a:pPr>
             <a:r>
@@ -6906,6 +6577,7 @@
         <a:solidFill>
           <a:srgbClr val="0A0E0A"/>
         </a:solidFill>
+        <a:effectLst/>
       </p:bgPr>
     </p:bg>
     <p:spTree>
@@ -6943,7 +6615,7 @@
           <a:bodyPr wrap="square" lIns="0" tIns="0" rIns="0" bIns="0" rtlCol="0" anchor="ctr"/>
           <a:lstStyle/>
           <a:p>
-            <a:pPr indent="0" marL="0">
+            <a:pPr marL="0" indent="0">
               <a:buNone/>
             </a:pPr>
             <a:r>
@@ -7032,7 +6704,7 @@
           <a:bodyPr wrap="square" lIns="0" tIns="0" rIns="0" bIns="0" rtlCol="0" anchor="ctr"/>
           <a:lstStyle/>
           <a:p>
-            <a:pPr indent="0" marL="0">
+            <a:pPr marL="0" indent="0">
               <a:buNone/>
             </a:pPr>
             <a:r>
@@ -7044,7 +6716,7 @@
                 <a:ea typeface="Consolas" pitchFamily="34" charset="-122"/>
                 <a:cs typeface="Consolas" pitchFamily="34" charset="-120"/>
               </a:rPr>
-              <a:t>&amp;gt; HARDWARE</a:t>
+              <a:t>HARDWARE</a:t>
             </a:r>
             <a:endParaRPr lang="en-US" sz="1300" dirty="0"/>
           </a:p>
@@ -7215,7 +6887,7 @@
           <a:bodyPr wrap="square" lIns="0" tIns="0" rIns="0" bIns="0" rtlCol="0" anchor="ctr"/>
           <a:lstStyle/>
           <a:p>
-            <a:pPr indent="0" marL="0">
+            <a:pPr marL="0" indent="0">
               <a:buNone/>
             </a:pPr>
             <a:r>
@@ -7227,7 +6899,7 @@
                 <a:ea typeface="Consolas" pitchFamily="34" charset="-122"/>
                 <a:cs typeface="Consolas" pitchFamily="34" charset="-120"/>
               </a:rPr>
-              <a:t>&amp;gt; SOFTWARE</a:t>
+              <a:t>SOFTWARE</a:t>
             </a:r>
             <a:endParaRPr lang="en-US" sz="1300" dirty="0"/>
           </a:p>
@@ -7422,7 +7094,7 @@
           <a:bodyPr wrap="square" lIns="0" tIns="0" rIns="0" bIns="0" rtlCol="0" anchor="ctr"/>
           <a:lstStyle/>
           <a:p>
-            <a:pPr indent="0" marL="0">
+            <a:pPr marL="0" indent="0">
               <a:buNone/>
             </a:pPr>
             <a:r>
@@ -7434,7 +7106,7 @@
                 <a:ea typeface="Consolas" pitchFamily="34" charset="-122"/>
                 <a:cs typeface="Consolas" pitchFamily="34" charset="-120"/>
               </a:rPr>
-              <a:t>&amp;gt; KNOWLEDGE</a:t>
+              <a:t>KNOWLEDGE</a:t>
             </a:r>
             <a:endParaRPr lang="en-US" sz="1300" dirty="0"/>
           </a:p>
@@ -7629,7 +7301,7 @@
           <a:bodyPr wrap="square" lIns="0" tIns="0" rIns="0" bIns="0" rtlCol="0" anchor="ctr"/>
           <a:lstStyle/>
           <a:p>
-            <a:pPr indent="0" marL="0">
+            <a:pPr marL="0" indent="0">
               <a:buNone/>
             </a:pPr>
             <a:r>
@@ -7663,6 +7335,7 @@
         <a:solidFill>
           <a:srgbClr val="0A0E0A"/>
         </a:solidFill>
+        <a:effectLst/>
       </p:bgPr>
     </p:bg>
     <p:spTree>
@@ -7700,7 +7373,7 @@
           <a:bodyPr wrap="square" lIns="0" tIns="0" rIns="0" bIns="0" rtlCol="0" anchor="ctr"/>
           <a:lstStyle/>
           <a:p>
-            <a:pPr indent="0" marL="0">
+            <a:pPr marL="0" indent="0">
               <a:buNone/>
             </a:pPr>
             <a:r>
@@ -7739,7 +7412,7 @@
           <a:bodyPr wrap="square" lIns="0" tIns="0" rIns="0" bIns="0" rtlCol="0" anchor="ctr"/>
           <a:lstStyle/>
           <a:p>
-            <a:pPr indent="0" marL="0">
+            <a:pPr marL="0" indent="0">
               <a:buNone/>
             </a:pPr>
             <a:r>
@@ -7853,7 +7526,7 @@
           <a:bodyPr wrap="square" lIns="0" tIns="0" rIns="0" bIns="0" rtlCol="0" anchor="ctr"/>
           <a:lstStyle/>
           <a:p>
-            <a:pPr algn="ctr" indent="0" marL="0">
+            <a:pPr marL="0" indent="0" algn="ctr">
               <a:buNone/>
             </a:pPr>
             <a:r>
@@ -7892,7 +7565,7 @@
           <a:bodyPr wrap="square" lIns="0" tIns="0" rIns="0" bIns="0" rtlCol="0" anchor="ctr"/>
           <a:lstStyle/>
           <a:p>
-            <a:pPr indent="0" marL="0">
+            <a:pPr marL="0" indent="0">
               <a:lnSpc>
                 <a:spcPts val="1300"/>
               </a:lnSpc>
@@ -7934,7 +7607,7 @@
           <a:bodyPr wrap="square" lIns="0" tIns="0" rIns="0" bIns="0" rtlCol="0" anchor="ctr"/>
           <a:lstStyle/>
           <a:p>
-            <a:pPr indent="0" marL="0">
+            <a:pPr marL="0" indent="0">
               <a:lnSpc>
                 <a:spcPts val="1300"/>
               </a:lnSpc>
@@ -7976,7 +7649,7 @@
           <a:bodyPr wrap="square" lIns="0" tIns="0" rIns="0" bIns="0" rtlCol="0" anchor="ctr"/>
           <a:lstStyle/>
           <a:p>
-            <a:pPr algn="ctr" indent="0" marL="0">
+            <a:pPr marL="0" indent="0" algn="ctr">
               <a:buNone/>
             </a:pPr>
             <a:r>
@@ -8067,7 +7740,7 @@
           <a:bodyPr wrap="square" lIns="0" tIns="0" rIns="0" bIns="0" rtlCol="0" anchor="ctr"/>
           <a:lstStyle/>
           <a:p>
-            <a:pPr algn="ctr" indent="0" marL="0">
+            <a:pPr marL="0" indent="0" algn="ctr">
               <a:buNone/>
             </a:pPr>
             <a:r>
@@ -8106,7 +7779,7 @@
           <a:bodyPr wrap="square" lIns="0" tIns="0" rIns="0" bIns="0" rtlCol="0" anchor="ctr"/>
           <a:lstStyle/>
           <a:p>
-            <a:pPr indent="0" marL="0">
+            <a:pPr marL="0" indent="0">
               <a:lnSpc>
                 <a:spcPts val="1300"/>
               </a:lnSpc>
@@ -8148,7 +7821,7 @@
           <a:bodyPr wrap="square" lIns="0" tIns="0" rIns="0" bIns="0" rtlCol="0" anchor="ctr"/>
           <a:lstStyle/>
           <a:p>
-            <a:pPr indent="0" marL="0">
+            <a:pPr marL="0" indent="0">
               <a:lnSpc>
                 <a:spcPts val="1300"/>
               </a:lnSpc>
@@ -8190,7 +7863,7 @@
           <a:bodyPr wrap="square" lIns="0" tIns="0" rIns="0" bIns="0" rtlCol="0" anchor="ctr"/>
           <a:lstStyle/>
           <a:p>
-            <a:pPr algn="ctr" indent="0" marL="0">
+            <a:pPr marL="0" indent="0" algn="ctr">
               <a:buNone/>
             </a:pPr>
             <a:r>
@@ -8281,7 +7954,7 @@
           <a:bodyPr wrap="square" lIns="0" tIns="0" rIns="0" bIns="0" rtlCol="0" anchor="ctr"/>
           <a:lstStyle/>
           <a:p>
-            <a:pPr algn="ctr" indent="0" marL="0">
+            <a:pPr marL="0" indent="0" algn="ctr">
               <a:buNone/>
             </a:pPr>
             <a:r>
@@ -8320,7 +7993,7 @@
           <a:bodyPr wrap="square" lIns="0" tIns="0" rIns="0" bIns="0" rtlCol="0" anchor="ctr"/>
           <a:lstStyle/>
           <a:p>
-            <a:pPr indent="0" marL="0">
+            <a:pPr marL="0" indent="0">
               <a:lnSpc>
                 <a:spcPts val="1300"/>
               </a:lnSpc>
@@ -8362,7 +8035,7 @@
           <a:bodyPr wrap="square" lIns="0" tIns="0" rIns="0" bIns="0" rtlCol="0" anchor="ctr"/>
           <a:lstStyle/>
           <a:p>
-            <a:pPr indent="0" marL="0">
+            <a:pPr marL="0" indent="0">
               <a:lnSpc>
                 <a:spcPts val="1300"/>
               </a:lnSpc>
@@ -8404,7 +8077,7 @@
           <a:bodyPr wrap="square" lIns="0" tIns="0" rIns="0" bIns="0" rtlCol="0" anchor="ctr"/>
           <a:lstStyle/>
           <a:p>
-            <a:pPr algn="ctr" indent="0" marL="0">
+            <a:pPr marL="0" indent="0" algn="ctr">
               <a:buNone/>
             </a:pPr>
             <a:r>
@@ -8495,7 +8168,7 @@
           <a:bodyPr wrap="square" lIns="0" tIns="0" rIns="0" bIns="0" rtlCol="0" anchor="ctr"/>
           <a:lstStyle/>
           <a:p>
-            <a:pPr algn="ctr" indent="0" marL="0">
+            <a:pPr marL="0" indent="0" algn="ctr">
               <a:buNone/>
             </a:pPr>
             <a:r>
@@ -8534,7 +8207,7 @@
           <a:bodyPr wrap="square" lIns="0" tIns="0" rIns="0" bIns="0" rtlCol="0" anchor="ctr"/>
           <a:lstStyle/>
           <a:p>
-            <a:pPr indent="0" marL="0">
+            <a:pPr marL="0" indent="0">
               <a:lnSpc>
                 <a:spcPts val="1300"/>
               </a:lnSpc>
@@ -8576,7 +8249,7 @@
           <a:bodyPr wrap="square" lIns="0" tIns="0" rIns="0" bIns="0" rtlCol="0" anchor="ctr"/>
           <a:lstStyle/>
           <a:p>
-            <a:pPr indent="0" marL="0">
+            <a:pPr marL="0" indent="0">
               <a:lnSpc>
                 <a:spcPts val="1300"/>
               </a:lnSpc>
@@ -8618,7 +8291,7 @@
           <a:bodyPr wrap="square" lIns="0" tIns="0" rIns="0" bIns="0" rtlCol="0" anchor="ctr"/>
           <a:lstStyle/>
           <a:p>
-            <a:pPr algn="ctr" indent="0" marL="0">
+            <a:pPr marL="0" indent="0" algn="ctr">
               <a:buNone/>
             </a:pPr>
             <a:r>
@@ -8709,7 +8382,7 @@
           <a:bodyPr wrap="square" lIns="0" tIns="0" rIns="0" bIns="0" rtlCol="0" anchor="ctr"/>
           <a:lstStyle/>
           <a:p>
-            <a:pPr algn="ctr" indent="0" marL="0">
+            <a:pPr marL="0" indent="0" algn="ctr">
               <a:buNone/>
             </a:pPr>
             <a:r>
@@ -8748,7 +8421,7 @@
           <a:bodyPr wrap="square" lIns="0" tIns="0" rIns="0" bIns="0" rtlCol="0" anchor="ctr"/>
           <a:lstStyle/>
           <a:p>
-            <a:pPr indent="0" marL="0">
+            <a:pPr marL="0" indent="0">
               <a:lnSpc>
                 <a:spcPts val="1300"/>
               </a:lnSpc>
@@ -8790,7 +8463,7 @@
           <a:bodyPr wrap="square" lIns="0" tIns="0" rIns="0" bIns="0" rtlCol="0" anchor="ctr"/>
           <a:lstStyle/>
           <a:p>
-            <a:pPr indent="0" marL="0">
+            <a:pPr marL="0" indent="0">
               <a:lnSpc>
                 <a:spcPts val="1300"/>
               </a:lnSpc>
@@ -8832,7 +8505,7 @@
           <a:bodyPr wrap="square" lIns="0" tIns="0" rIns="0" bIns="0" rtlCol="0" anchor="ctr"/>
           <a:lstStyle/>
           <a:p>
-            <a:pPr algn="l" indent="0" marL="0">
+            <a:pPr marL="0" indent="0" algn="l">
               <a:buNone/>
             </a:pPr>
             <a:r>
@@ -8871,7 +8544,7 @@
           <a:bodyPr wrap="square" lIns="0" tIns="0" rIns="0" bIns="0" rtlCol="0" anchor="ctr"/>
           <a:lstStyle/>
           <a:p>
-            <a:pPr algn="r" indent="0" marL="0">
+            <a:pPr marL="0" indent="0" algn="r">
               <a:buNone/>
             </a:pPr>
             <a:r>
@@ -8905,6 +8578,7 @@
         <a:solidFill>
           <a:srgbClr val="0A0E0A"/>
         </a:solidFill>
+        <a:effectLst/>
       </p:bgPr>
     </p:bg>
     <p:spTree>
@@ -8942,7 +8616,7 @@
           <a:bodyPr wrap="square" lIns="0" tIns="0" rIns="0" bIns="0" rtlCol="0" anchor="ctr"/>
           <a:lstStyle/>
           <a:p>
-            <a:pPr indent="0" marL="0">
+            <a:pPr marL="0" indent="0">
               <a:buNone/>
             </a:pPr>
             <a:r>
@@ -8981,7 +8655,7 @@
           <a:bodyPr wrap="square" lIns="0" tIns="0" rIns="0" bIns="0" rtlCol="0" anchor="ctr"/>
           <a:lstStyle/>
           <a:p>
-            <a:pPr indent="0" marL="0">
+            <a:pPr marL="0" indent="0">
               <a:buNone/>
             </a:pPr>
             <a:r>
@@ -9095,7 +8769,7 @@
           <a:bodyPr wrap="square" lIns="0" tIns="0" rIns="0" bIns="0" rtlCol="0" anchor="ctr"/>
           <a:lstStyle/>
           <a:p>
-            <a:pPr algn="ctr" indent="0" marL="0">
+            <a:pPr marL="0" indent="0" algn="ctr">
               <a:buNone/>
             </a:pPr>
             <a:r>
@@ -9134,7 +8808,7 @@
           <a:bodyPr wrap="square" lIns="0" tIns="0" rIns="0" bIns="0" rtlCol="0" anchor="ctr"/>
           <a:lstStyle/>
           <a:p>
-            <a:pPr indent="0" marL="0">
+            <a:pPr marL="0" indent="0">
               <a:lnSpc>
                 <a:spcPts val="1400"/>
               </a:lnSpc>
@@ -9176,7 +8850,7 @@
           <a:bodyPr wrap="square" lIns="0" tIns="0" rIns="0" bIns="0" rtlCol="0" anchor="ctr"/>
           <a:lstStyle/>
           <a:p>
-            <a:pPr indent="0" marL="0">
+            <a:pPr marL="0" indent="0">
               <a:lnSpc>
                 <a:spcPts val="1400"/>
               </a:lnSpc>
@@ -9218,7 +8892,7 @@
           <a:bodyPr wrap="square" lIns="0" tIns="0" rIns="0" bIns="0" rtlCol="0" anchor="ctr"/>
           <a:lstStyle/>
           <a:p>
-            <a:pPr algn="ctr" indent="0" marL="0">
+            <a:pPr marL="0" indent="0" algn="ctr">
               <a:buNone/>
             </a:pPr>
             <a:r>
@@ -9309,7 +8983,7 @@
           <a:bodyPr wrap="square" lIns="0" tIns="0" rIns="0" bIns="0" rtlCol="0" anchor="ctr"/>
           <a:lstStyle/>
           <a:p>
-            <a:pPr algn="ctr" indent="0" marL="0">
+            <a:pPr marL="0" indent="0" algn="ctr">
               <a:buNone/>
             </a:pPr>
             <a:r>
@@ -9348,7 +9022,7 @@
           <a:bodyPr wrap="square" lIns="0" tIns="0" rIns="0" bIns="0" rtlCol="0" anchor="ctr"/>
           <a:lstStyle/>
           <a:p>
-            <a:pPr indent="0" marL="0">
+            <a:pPr marL="0" indent="0">
               <a:lnSpc>
                 <a:spcPts val="1400"/>
               </a:lnSpc>
@@ -9390,7 +9064,7 @@
           <a:bodyPr wrap="square" lIns="0" tIns="0" rIns="0" bIns="0" rtlCol="0" anchor="ctr"/>
           <a:lstStyle/>
           <a:p>
-            <a:pPr indent="0" marL="0">
+            <a:pPr marL="0" indent="0">
               <a:lnSpc>
                 <a:spcPts val="1400"/>
               </a:lnSpc>
@@ -9432,7 +9106,7 @@
           <a:bodyPr wrap="square" lIns="0" tIns="0" rIns="0" bIns="0" rtlCol="0" anchor="ctr"/>
           <a:lstStyle/>
           <a:p>
-            <a:pPr algn="ctr" indent="0" marL="0">
+            <a:pPr marL="0" indent="0" algn="ctr">
               <a:buNone/>
             </a:pPr>
             <a:r>
@@ -9523,7 +9197,7 @@
           <a:bodyPr wrap="square" lIns="0" tIns="0" rIns="0" bIns="0" rtlCol="0" anchor="ctr"/>
           <a:lstStyle/>
           <a:p>
-            <a:pPr algn="ctr" indent="0" marL="0">
+            <a:pPr marL="0" indent="0" algn="ctr">
               <a:buNone/>
             </a:pPr>
             <a:r>
@@ -9562,7 +9236,7 @@
           <a:bodyPr wrap="square" lIns="0" tIns="0" rIns="0" bIns="0" rtlCol="0" anchor="ctr"/>
           <a:lstStyle/>
           <a:p>
-            <a:pPr indent="0" marL="0">
+            <a:pPr marL="0" indent="0">
               <a:lnSpc>
                 <a:spcPts val="1400"/>
               </a:lnSpc>
@@ -9604,7 +9278,7 @@
           <a:bodyPr wrap="square" lIns="0" tIns="0" rIns="0" bIns="0" rtlCol="0" anchor="ctr"/>
           <a:lstStyle/>
           <a:p>
-            <a:pPr indent="0" marL="0">
+            <a:pPr marL="0" indent="0">
               <a:lnSpc>
                 <a:spcPts val="1400"/>
               </a:lnSpc>
@@ -9646,7 +9320,7 @@
           <a:bodyPr wrap="square" lIns="0" tIns="0" rIns="0" bIns="0" rtlCol="0" anchor="ctr"/>
           <a:lstStyle/>
           <a:p>
-            <a:pPr algn="ctr" indent="0" marL="0">
+            <a:pPr marL="0" indent="0" algn="ctr">
               <a:buNone/>
             </a:pPr>
             <a:r>
@@ -9737,7 +9411,7 @@
           <a:bodyPr wrap="square" lIns="0" tIns="0" rIns="0" bIns="0" rtlCol="0" anchor="ctr"/>
           <a:lstStyle/>
           <a:p>
-            <a:pPr algn="ctr" indent="0" marL="0">
+            <a:pPr marL="0" indent="0" algn="ctr">
               <a:buNone/>
             </a:pPr>
             <a:r>
@@ -9776,7 +9450,7 @@
           <a:bodyPr wrap="square" lIns="0" tIns="0" rIns="0" bIns="0" rtlCol="0" anchor="ctr"/>
           <a:lstStyle/>
           <a:p>
-            <a:pPr indent="0" marL="0">
+            <a:pPr marL="0" indent="0">
               <a:lnSpc>
                 <a:spcPts val="1400"/>
               </a:lnSpc>
@@ -9818,7 +9492,7 @@
           <a:bodyPr wrap="square" lIns="0" tIns="0" rIns="0" bIns="0" rtlCol="0" anchor="ctr"/>
           <a:lstStyle/>
           <a:p>
-            <a:pPr indent="0" marL="0">
+            <a:pPr marL="0" indent="0">
               <a:lnSpc>
                 <a:spcPts val="1400"/>
               </a:lnSpc>
@@ -9860,7 +9534,7 @@
           <a:bodyPr wrap="square" lIns="0" tIns="0" rIns="0" bIns="0" rtlCol="0" anchor="ctr"/>
           <a:lstStyle/>
           <a:p>
-            <a:pPr algn="l" indent="0" marL="0">
+            <a:pPr marL="0" indent="0" algn="l">
               <a:buNone/>
             </a:pPr>
             <a:r>
@@ -9899,7 +9573,7 @@
           <a:bodyPr wrap="square" lIns="0" tIns="0" rIns="0" bIns="0" rtlCol="0" anchor="ctr"/>
           <a:lstStyle/>
           <a:p>
-            <a:pPr algn="r" indent="0" marL="0">
+            <a:pPr marL="0" indent="0" algn="r">
               <a:buNone/>
             </a:pPr>
             <a:r>
@@ -9933,6 +9607,7 @@
         <a:solidFill>
           <a:srgbClr val="0A0E0A"/>
         </a:solidFill>
+        <a:effectLst/>
       </p:bgPr>
     </p:bg>
     <p:spTree>
@@ -9970,7 +9645,7 @@
           <a:bodyPr wrap="square" lIns="0" tIns="0" rIns="0" bIns="0" rtlCol="0" anchor="ctr"/>
           <a:lstStyle/>
           <a:p>
-            <a:pPr indent="0" marL="0">
+            <a:pPr marL="0" indent="0">
               <a:buNone/>
             </a:pPr>
             <a:r>
@@ -10009,7 +9684,7 @@
           <a:bodyPr wrap="square" lIns="0" tIns="0" rIns="0" bIns="0" rtlCol="0" anchor="ctr"/>
           <a:lstStyle/>
           <a:p>
-            <a:pPr indent="0" marL="0">
+            <a:pPr marL="0" indent="0">
               <a:buNone/>
             </a:pPr>
             <a:r>
@@ -10098,7 +9773,7 @@
           <a:bodyPr wrap="square" lIns="0" tIns="0" rIns="0" bIns="0" rtlCol="0" anchor="ctr"/>
           <a:lstStyle/>
           <a:p>
-            <a:pPr indent="0" marL="0">
+            <a:pPr marL="0" indent="0">
               <a:buNone/>
             </a:pPr>
             <a:r>
@@ -10161,7 +9836,7 @@
             <a:endParaRPr lang="en-US" sz="1250" dirty="0"/>
           </a:p>
           <a:p>
-            <a:pPr indent="0" marL="0">
+            <a:pPr marL="0" indent="0">
               <a:lnSpc>
                 <a:spcPts val="1900"/>
               </a:lnSpc>
@@ -10184,7 +9859,7 @@
             <a:endParaRPr lang="en-US" sz="1250" dirty="0"/>
           </a:p>
           <a:p>
-            <a:pPr indent="0" marL="0">
+            <a:pPr marL="0" indent="0">
               <a:lnSpc>
                 <a:spcPts val="1900"/>
               </a:lnSpc>
@@ -10207,7 +9882,7 @@
             <a:endParaRPr lang="en-US" sz="1250" dirty="0"/>
           </a:p>
           <a:p>
-            <a:pPr indent="0" marL="0">
+            <a:pPr marL="0" indent="0">
               <a:lnSpc>
                 <a:spcPts val="1900"/>
               </a:lnSpc>
@@ -10276,7 +9951,7 @@
           <a:bodyPr wrap="square" lIns="0" tIns="0" rIns="0" bIns="0" rtlCol="0" anchor="ctr"/>
           <a:lstStyle/>
           <a:p>
-            <a:pPr indent="0" marL="0">
+            <a:pPr marL="0" indent="0">
               <a:buNone/>
             </a:pPr>
             <a:r>
@@ -10339,7 +10014,7 @@
             <a:endParaRPr lang="en-US" sz="1250" dirty="0"/>
           </a:p>
           <a:p>
-            <a:pPr indent="0" marL="0">
+            <a:pPr marL="0" indent="0">
               <a:lnSpc>
                 <a:spcPts val="1900"/>
               </a:lnSpc>
@@ -10362,7 +10037,7 @@
             <a:endParaRPr lang="en-US" sz="1250" dirty="0"/>
           </a:p>
           <a:p>
-            <a:pPr indent="0" marL="0">
+            <a:pPr marL="0" indent="0">
               <a:lnSpc>
                 <a:spcPts val="1900"/>
               </a:lnSpc>
@@ -10385,7 +10060,7 @@
             <a:endParaRPr lang="en-US" sz="1250" dirty="0"/>
           </a:p>
           <a:p>
-            <a:pPr indent="0" marL="0">
+            <a:pPr marL="0" indent="0">
               <a:lnSpc>
                 <a:spcPts val="1900"/>
               </a:lnSpc>
@@ -10427,7 +10102,7 @@
           <a:bodyPr wrap="square" lIns="0" tIns="0" rIns="0" bIns="0" rtlCol="0" anchor="ctr"/>
           <a:lstStyle/>
           <a:p>
-            <a:pPr algn="l" indent="0" marL="0">
+            <a:pPr marL="0" indent="0" algn="l">
               <a:buNone/>
             </a:pPr>
             <a:r>
@@ -10466,7 +10141,7 @@
           <a:bodyPr wrap="square" lIns="0" tIns="0" rIns="0" bIns="0" rtlCol="0" anchor="ctr"/>
           <a:lstStyle/>
           <a:p>
-            <a:pPr algn="r" indent="0" marL="0">
+            <a:pPr marL="0" indent="0" algn="r">
               <a:buNone/>
             </a:pPr>
             <a:r>
@@ -10500,6 +10175,7 @@
         <a:solidFill>
           <a:srgbClr val="0A0E0A"/>
         </a:solidFill>
+        <a:effectLst/>
       </p:bgPr>
     </p:bg>
     <p:spTree>
@@ -10537,7 +10213,7 @@
           <a:bodyPr wrap="square" lIns="0" tIns="0" rIns="0" bIns="0" rtlCol="0" anchor="ctr"/>
           <a:lstStyle/>
           <a:p>
-            <a:pPr indent="0" marL="0">
+            <a:pPr marL="0" indent="0">
               <a:buNone/>
             </a:pPr>
             <a:r>
@@ -10576,7 +10252,7 @@
           <a:bodyPr wrap="square" lIns="0" tIns="0" rIns="0" bIns="0" rtlCol="0" anchor="ctr"/>
           <a:lstStyle/>
           <a:p>
-            <a:pPr indent="0" marL="0">
+            <a:pPr marL="0" indent="0">
               <a:buNone/>
             </a:pPr>
             <a:r>
@@ -10745,11 +10421,11 @@
           <a:bodyPr wrap="square" lIns="0" tIns="0" rIns="0" bIns="0" rtlCol="0" anchor="ctr"/>
           <a:lstStyle/>
           <a:p>
-            <a:pPr indent="0" marL="0">
-              <a:buNone/>
-            </a:pPr>
-            <a:r>
-              <a:rPr lang="en-US" sz="1000" dirty="0">
+            <a:pPr marL="0" indent="0">
+              <a:buNone/>
+            </a:pPr>
+            <a:r>
+              <a:rPr lang="en-US" sz="1000" dirty="0" err="1">
                 <a:solidFill>
                   <a:srgbClr val="5FBF5F"/>
                 </a:solidFill>
@@ -10757,7 +10433,7 @@
                 <a:ea typeface="Consolas" pitchFamily="34" charset="-122"/>
                 <a:cs typeface="Consolas" pitchFamily="34" charset="-120"/>
               </a:rPr>
-              <a:t>secure-portal@aiou:~$</a:t>
+              <a:t>secure-portal@aiou</a:t>
             </a:r>
             <a:endParaRPr lang="en-US" sz="1000" dirty="0"/>
           </a:p>
@@ -10784,7 +10460,7 @@
           <a:bodyPr wrap="square" lIns="0" tIns="0" rIns="0" bIns="0" rtlCol="0" anchor="ctr"/>
           <a:lstStyle/>
           <a:p>
-            <a:pPr indent="0" marL="0">
+            <a:pPr marL="0" indent="0">
               <a:buNone/>
             </a:pPr>
             <a:r>
@@ -10823,7 +10499,7 @@
           <a:bodyPr wrap="square" lIns="0" tIns="0" rIns="0" bIns="0" rtlCol="0" anchor="ctr"/>
           <a:lstStyle/>
           <a:p>
-            <a:pPr indent="0" marL="0">
+            <a:pPr marL="0" indent="0">
               <a:buNone/>
             </a:pPr>
             <a:r>
@@ -10889,7 +10565,7 @@
           <a:bodyPr wrap="square" lIns="0" tIns="0" rIns="0" bIns="0" rtlCol="0" anchor="ctr"/>
           <a:lstStyle/>
           <a:p>
-            <a:pPr indent="0" marL="0">
+            <a:pPr marL="0" indent="0">
               <a:buNone/>
             </a:pPr>
             <a:r>
@@ -10928,7 +10604,7 @@
           <a:bodyPr wrap="square" lIns="0" tIns="0" rIns="0" bIns="0" rtlCol="0" anchor="ctr"/>
           <a:lstStyle/>
           <a:p>
-            <a:pPr indent="0" marL="0">
+            <a:pPr marL="0" indent="0">
               <a:buNone/>
             </a:pPr>
             <a:r>
@@ -10994,7 +10670,7 @@
           <a:bodyPr wrap="square" lIns="0" tIns="0" rIns="0" bIns="0" rtlCol="0" anchor="ctr"/>
           <a:lstStyle/>
           <a:p>
-            <a:pPr indent="0" marL="0">
+            <a:pPr marL="0" indent="0">
               <a:buNone/>
             </a:pPr>
             <a:r>
@@ -11055,7 +10731,7 @@
           <a:bodyPr wrap="square" lIns="0" tIns="0" rIns="0" bIns="0" rtlCol="0" anchor="ctr"/>
           <a:lstStyle/>
           <a:p>
-            <a:pPr algn="ctr" indent="0" marL="0">
+            <a:pPr marL="0" indent="0" algn="ctr">
               <a:buNone/>
             </a:pPr>
             <a:r>
@@ -11067,7 +10743,7 @@
                 <a:ea typeface="Consolas" pitchFamily="34" charset="-122"/>
                 <a:cs typeface="Consolas" pitchFamily="34" charset="-120"/>
               </a:rPr>
-              <a:t>&amp;gt; AUTHENTICATE_</a:t>
+              <a:t>AUTHENTICATE</a:t>
             </a:r>
             <a:endParaRPr lang="en-US" sz="1000" dirty="0"/>
           </a:p>
@@ -11121,7 +10797,7 @@
           <a:bodyPr wrap="square" lIns="0" tIns="0" rIns="0" bIns="0" rtlCol="0" anchor="ctr"/>
           <a:lstStyle/>
           <a:p>
-            <a:pPr indent="0" marL="0">
+            <a:pPr marL="0" indent="0">
               <a:lnSpc>
                 <a:spcPts val="1100"/>
               </a:lnSpc>
@@ -11163,7 +10839,7 @@
           <a:bodyPr wrap="square" lIns="0" tIns="0" rIns="0" bIns="0" rtlCol="0" anchor="ctr"/>
           <a:lstStyle/>
           <a:p>
-            <a:pPr indent="0" marL="0">
+            <a:pPr marL="0" indent="0">
               <a:lnSpc>
                 <a:spcPts val="1800"/>
               </a:lnSpc>
@@ -11282,7 +10958,7 @@
             <a:endParaRPr lang="en-US" sz="1400" dirty="0"/>
           </a:p>
           <a:p>
-            <a:pPr indent="0" marL="0">
+            <a:pPr marL="0" indent="0">
               <a:lnSpc>
                 <a:spcPts val="1800"/>
               </a:lnSpc>
@@ -11324,7 +11000,7 @@
           <a:bodyPr wrap="square" lIns="0" tIns="0" rIns="0" bIns="0" rtlCol="0" anchor="ctr"/>
           <a:lstStyle/>
           <a:p>
-            <a:pPr algn="l" indent="0" marL="0">
+            <a:pPr marL="0" indent="0" algn="l">
               <a:buNone/>
             </a:pPr>
             <a:r>
@@ -11363,7 +11039,7 @@
           <a:bodyPr wrap="square" lIns="0" tIns="0" rIns="0" bIns="0" rtlCol="0" anchor="ctr"/>
           <a:lstStyle/>
           <a:p>
-            <a:pPr algn="r" indent="0" marL="0">
+            <a:pPr marL="0" indent="0" algn="r">
               <a:buNone/>
             </a:pPr>
             <a:r>
@@ -11397,6 +11073,7 @@
         <a:solidFill>
           <a:srgbClr val="0A0E0A"/>
         </a:solidFill>
+        <a:effectLst/>
       </p:bgPr>
     </p:bg>
     <p:spTree>
@@ -11434,7 +11111,7 @@
           <a:bodyPr wrap="square" lIns="0" tIns="0" rIns="0" bIns="0" rtlCol="0" anchor="ctr"/>
           <a:lstStyle/>
           <a:p>
-            <a:pPr indent="0" marL="0">
+            <a:pPr marL="0" indent="0">
               <a:buNone/>
             </a:pPr>
             <a:r>
@@ -11473,7 +11150,7 @@
           <a:bodyPr wrap="square" lIns="0" tIns="0" rIns="0" bIns="0" rtlCol="0" anchor="ctr"/>
           <a:lstStyle/>
           <a:p>
-            <a:pPr indent="0" marL="0">
+            <a:pPr marL="0" indent="0">
               <a:buNone/>
             </a:pPr>
             <a:r>
@@ -11589,7 +11266,7 @@
           <a:bodyPr wrap="square" lIns="0" tIns="0" rIns="0" bIns="0" rtlCol="0" anchor="ctr"/>
           <a:lstStyle/>
           <a:p>
-            <a:pPr algn="ctr" indent="0" marL="0">
+            <a:pPr marL="0" indent="0" algn="ctr">
               <a:buNone/>
             </a:pPr>
             <a:r>
@@ -11628,7 +11305,7 @@
           <a:bodyPr wrap="square" lIns="0" tIns="0" rIns="0" bIns="0" rtlCol="0" anchor="ctr"/>
           <a:lstStyle/>
           <a:p>
-            <a:pPr indent="0" marL="0">
+            <a:pPr marL="0" indent="0">
               <a:buNone/>
             </a:pPr>
             <a:r>
@@ -11667,7 +11344,7 @@
           <a:bodyPr wrap="square" lIns="0" tIns="0" rIns="0" bIns="0" rtlCol="0" anchor="ctr"/>
           <a:lstStyle/>
           <a:p>
-            <a:pPr indent="0" marL="0">
+            <a:pPr marL="0" indent="0">
               <a:buNone/>
             </a:pPr>
             <a:r>
@@ -11760,7 +11437,7 @@
           <a:bodyPr wrap="square" lIns="0" tIns="0" rIns="0" bIns="0" rtlCol="0" anchor="ctr"/>
           <a:lstStyle/>
           <a:p>
-            <a:pPr algn="ctr" indent="0" marL="0">
+            <a:pPr marL="0" indent="0" algn="ctr">
               <a:buNone/>
             </a:pPr>
             <a:r>
@@ -11799,7 +11476,7 @@
           <a:bodyPr wrap="square" lIns="0" tIns="0" rIns="0" bIns="0" rtlCol="0" anchor="ctr"/>
           <a:lstStyle/>
           <a:p>
-            <a:pPr indent="0" marL="0">
+            <a:pPr marL="0" indent="0">
               <a:buNone/>
             </a:pPr>
             <a:r>
@@ -11838,7 +11515,7 @@
           <a:bodyPr wrap="square" lIns="0" tIns="0" rIns="0" bIns="0" rtlCol="0" anchor="ctr"/>
           <a:lstStyle/>
           <a:p>
-            <a:pPr indent="0" marL="0">
+            <a:pPr marL="0" indent="0">
               <a:buNone/>
             </a:pPr>
             <a:r>
@@ -11931,7 +11608,7 @@
           <a:bodyPr wrap="square" lIns="0" tIns="0" rIns="0" bIns="0" rtlCol="0" anchor="ctr"/>
           <a:lstStyle/>
           <a:p>
-            <a:pPr algn="ctr" indent="0" marL="0">
+            <a:pPr marL="0" indent="0" algn="ctr">
               <a:buNone/>
             </a:pPr>
             <a:r>
@@ -11970,7 +11647,7 @@
           <a:bodyPr wrap="square" lIns="0" tIns="0" rIns="0" bIns="0" rtlCol="0" anchor="ctr"/>
           <a:lstStyle/>
           <a:p>
-            <a:pPr indent="0" marL="0">
+            <a:pPr marL="0" indent="0">
               <a:buNone/>
             </a:pPr>
             <a:r>
@@ -12009,7 +11686,7 @@
           <a:bodyPr wrap="square" lIns="0" tIns="0" rIns="0" bIns="0" rtlCol="0" anchor="ctr"/>
           <a:lstStyle/>
           <a:p>
-            <a:pPr indent="0" marL="0">
+            <a:pPr marL="0" indent="0">
               <a:buNone/>
             </a:pPr>
             <a:r>
@@ -12102,7 +11779,7 @@
           <a:bodyPr wrap="square" lIns="0" tIns="0" rIns="0" bIns="0" rtlCol="0" anchor="ctr"/>
           <a:lstStyle/>
           <a:p>
-            <a:pPr algn="ctr" indent="0" marL="0">
+            <a:pPr marL="0" indent="0" algn="ctr">
               <a:buNone/>
             </a:pPr>
             <a:r>
@@ -12141,7 +11818,7 @@
           <a:bodyPr wrap="square" lIns="0" tIns="0" rIns="0" bIns="0" rtlCol="0" anchor="ctr"/>
           <a:lstStyle/>
           <a:p>
-            <a:pPr indent="0" marL="0">
+            <a:pPr marL="0" indent="0">
               <a:buNone/>
             </a:pPr>
             <a:r>
@@ -12180,7 +11857,7 @@
           <a:bodyPr wrap="square" lIns="0" tIns="0" rIns="0" bIns="0" rtlCol="0" anchor="ctr"/>
           <a:lstStyle/>
           <a:p>
-            <a:pPr indent="0" marL="0">
+            <a:pPr marL="0" indent="0">
               <a:buNone/>
             </a:pPr>
             <a:r>
@@ -12273,7 +11950,7 @@
           <a:bodyPr wrap="square" lIns="0" tIns="0" rIns="0" bIns="0" rtlCol="0" anchor="ctr"/>
           <a:lstStyle/>
           <a:p>
-            <a:pPr algn="ctr" indent="0" marL="0">
+            <a:pPr marL="0" indent="0" algn="ctr">
               <a:buNone/>
             </a:pPr>
             <a:r>
@@ -12312,7 +11989,7 @@
           <a:bodyPr wrap="square" lIns="0" tIns="0" rIns="0" bIns="0" rtlCol="0" anchor="ctr"/>
           <a:lstStyle/>
           <a:p>
-            <a:pPr indent="0" marL="0">
+            <a:pPr marL="0" indent="0">
               <a:buNone/>
             </a:pPr>
             <a:r>
@@ -12351,7 +12028,7 @@
           <a:bodyPr wrap="square" lIns="0" tIns="0" rIns="0" bIns="0" rtlCol="0" anchor="ctr"/>
           <a:lstStyle/>
           <a:p>
-            <a:pPr indent="0" marL="0">
+            <a:pPr marL="0" indent="0">
               <a:buNone/>
             </a:pPr>
             <a:r>
@@ -12390,7 +12067,7 @@
           <a:bodyPr wrap="square" lIns="0" tIns="0" rIns="0" bIns="0" rtlCol="0" anchor="ctr"/>
           <a:lstStyle/>
           <a:p>
-            <a:pPr algn="l" indent="0" marL="0">
+            <a:pPr marL="0" indent="0" algn="l">
               <a:buNone/>
             </a:pPr>
             <a:r>
@@ -12429,7 +12106,7 @@
           <a:bodyPr wrap="square" lIns="0" tIns="0" rIns="0" bIns="0" rtlCol="0" anchor="ctr"/>
           <a:lstStyle/>
           <a:p>
-            <a:pPr algn="r" indent="0" marL="0">
+            <a:pPr marL="0" indent="0" algn="r">
               <a:buNone/>
             </a:pPr>
             <a:r>
@@ -12748,4 +12425,299 @@
     </a:ext>
   </a:extLst>
 </a:theme>
+</file>
+
+<file path=ppt/theme/theme2.xml><?xml version="1.0" encoding="utf-8"?>
+<a:theme xmlns:a="http://schemas.openxmlformats.org/drawingml/2006/main" name="Office Theme">
+  <a:themeElements>
+    <a:clrScheme name="Office">
+      <a:dk1>
+        <a:sysClr val="windowText" lastClr="000000"/>
+      </a:dk1>
+      <a:lt1>
+        <a:sysClr val="window" lastClr="FFFFFF"/>
+      </a:lt1>
+      <a:dk2>
+        <a:srgbClr val="44546A"/>
+      </a:dk2>
+      <a:lt2>
+        <a:srgbClr val="E7E6E6"/>
+      </a:lt2>
+      <a:accent1>
+        <a:srgbClr val="4472C4"/>
+      </a:accent1>
+      <a:accent2>
+        <a:srgbClr val="ED7D31"/>
+      </a:accent2>
+      <a:accent3>
+        <a:srgbClr val="A5A5A5"/>
+      </a:accent3>
+      <a:accent4>
+        <a:srgbClr val="FFC000"/>
+      </a:accent4>
+      <a:accent5>
+        <a:srgbClr val="5B9BD5"/>
+      </a:accent5>
+      <a:accent6>
+        <a:srgbClr val="70AD47"/>
+      </a:accent6>
+      <a:hlink>
+        <a:srgbClr val="0563C1"/>
+      </a:hlink>
+      <a:folHlink>
+        <a:srgbClr val="954F72"/>
+      </a:folHlink>
+    </a:clrScheme>
+    <a:fontScheme name="Office">
+      <a:majorFont>
+        <a:latin typeface="Calibri Light" panose="020F0302020204030204"/>
+        <a:ea typeface=""/>
+        <a:cs typeface=""/>
+        <a:font script="Jpan" typeface="游ゴシック Light"/>
+        <a:font script="Hang" typeface="맑은 고딕"/>
+        <a:font script="Hans" typeface="等线 Light"/>
+        <a:font script="Hant" typeface="新細明體"/>
+        <a:font script="Arab" typeface="Times New Roman"/>
+        <a:font script="Hebr" typeface="Times New Roman"/>
+        <a:font script="Thai" typeface="Angsana New"/>
+        <a:font script="Ethi" typeface="Nyala"/>
+        <a:font script="Beng" typeface="Vrinda"/>
+        <a:font script="Gujr" typeface="Shruti"/>
+        <a:font script="Khmr" typeface="MoolBoran"/>
+        <a:font script="Knda" typeface="Tunga"/>
+        <a:font script="Guru" typeface="Raavi"/>
+        <a:font script="Cans" typeface="Euphemia"/>
+        <a:font script="Cher" typeface="Plantagenet Cherokee"/>
+        <a:font script="Yiii" typeface="Microsoft Yi Baiti"/>
+        <a:font script="Tibt" typeface="Microsoft Himalaya"/>
+        <a:font script="Thaa" typeface="MV Boli"/>
+        <a:font script="Deva" typeface="Mangal"/>
+        <a:font script="Telu" typeface="Gautami"/>
+        <a:font script="Taml" typeface="Latha"/>
+        <a:font script="Syrc" typeface="Estrangelo Edessa"/>
+        <a:font script="Orya" typeface="Kalinga"/>
+        <a:font script="Mlym" typeface="Kartika"/>
+        <a:font script="Laoo" typeface="DokChampa"/>
+        <a:font script="Sinh" typeface="Iskoola Pota"/>
+        <a:font script="Mong" typeface="Mongolian Baiti"/>
+        <a:font script="Viet" typeface="Times New Roman"/>
+        <a:font script="Uigh" typeface="Microsoft Uighur"/>
+        <a:font script="Geor" typeface="Sylfaen"/>
+        <a:font script="Armn" typeface="Arial"/>
+        <a:font script="Bugi" typeface="Leelawadee UI"/>
+        <a:font script="Bopo" typeface="Microsoft JhengHei"/>
+        <a:font script="Java" typeface="Javanese Text"/>
+        <a:font script="Lisu" typeface="Segoe UI"/>
+        <a:font script="Mymr" typeface="Myanmar Text"/>
+        <a:font script="Nkoo" typeface="Ebrima"/>
+        <a:font script="Olck" typeface="Nirmala UI"/>
+        <a:font script="Osma" typeface="Ebrima"/>
+        <a:font script="Phag" typeface="Phagspa"/>
+        <a:font script="Syrn" typeface="Estrangelo Edessa"/>
+        <a:font script="Syrj" typeface="Estrangelo Edessa"/>
+        <a:font script="Syre" typeface="Estrangelo Edessa"/>
+        <a:font script="Sora" typeface="Nirmala UI"/>
+        <a:font script="Tale" typeface="Microsoft Tai Le"/>
+        <a:font script="Talu" typeface="Microsoft New Tai Lue"/>
+        <a:font script="Tfng" typeface="Ebrima"/>
+      </a:majorFont>
+      <a:minorFont>
+        <a:latin typeface="Calibri" panose="020F0502020204030204"/>
+        <a:ea typeface=""/>
+        <a:cs typeface=""/>
+        <a:font script="Jpan" typeface="游ゴシック"/>
+        <a:font script="Hang" typeface="맑은 고딕"/>
+        <a:font script="Hans" typeface="等线"/>
+        <a:font script="Hant" typeface="新細明體"/>
+        <a:font script="Arab" typeface="Arial"/>
+        <a:font script="Hebr" typeface="Arial"/>
+        <a:font script="Thai" typeface="Cordia New"/>
+        <a:font script="Ethi" typeface="Nyala"/>
+        <a:font script="Beng" typeface="Vrinda"/>
+        <a:font script="Gujr" typeface="Shruti"/>
+        <a:font script="Khmr" typeface="DaunPenh"/>
+        <a:font script="Knda" typeface="Tunga"/>
+        <a:font script="Guru" typeface="Raavi"/>
+        <a:font script="Cans" typeface="Euphemia"/>
+        <a:font script="Cher" typeface="Plantagenet Cherokee"/>
+        <a:font script="Yiii" typeface="Microsoft Yi Baiti"/>
+        <a:font script="Tibt" typeface="Microsoft Himalaya"/>
+        <a:font script="Thaa" typeface="MV Boli"/>
+        <a:font script="Deva" typeface="Mangal"/>
+        <a:font script="Telu" typeface="Gautami"/>
+        <a:font script="Taml" typeface="Latha"/>
+        <a:font script="Syrc" typeface="Estrangelo Edessa"/>
+        <a:font script="Orya" typeface="Kalinga"/>
+        <a:font script="Mlym" typeface="Kartika"/>
+        <a:font script="Laoo" typeface="DokChampa"/>
+        <a:font script="Sinh" typeface="Iskoola Pota"/>
+        <a:font script="Mong" typeface="Mongolian Baiti"/>
+        <a:font script="Viet" typeface="Arial"/>
+        <a:font script="Uigh" typeface="Microsoft Uighur"/>
+        <a:font script="Geor" typeface="Sylfaen"/>
+        <a:font script="Armn" typeface="Arial"/>
+        <a:font script="Bugi" typeface="Leelawadee UI"/>
+        <a:font script="Bopo" typeface="Microsoft JhengHei"/>
+        <a:font script="Java" typeface="Javanese Text"/>
+        <a:font script="Lisu" typeface="Segoe UI"/>
+        <a:font script="Mymr" typeface="Myanmar Text"/>
+        <a:font script="Nkoo" typeface="Ebrima"/>
+        <a:font script="Olck" typeface="Nirmala UI"/>
+        <a:font script="Osma" typeface="Ebrima"/>
+        <a:font script="Phag" typeface="Phagspa"/>
+        <a:font script="Syrn" typeface="Estrangelo Edessa"/>
+        <a:font script="Syrj" typeface="Estrangelo Edessa"/>
+        <a:font script="Syre" typeface="Estrangelo Edessa"/>
+        <a:font script="Sora" typeface="Nirmala UI"/>
+        <a:font script="Tale" typeface="Microsoft Tai Le"/>
+        <a:font script="Talu" typeface="Microsoft New Tai Lue"/>
+        <a:font script="Tfng" typeface="Ebrima"/>
+      </a:minorFont>
+    </a:fontScheme>
+    <a:fmtScheme name="Office">
+      <a:fillStyleLst>
+        <a:solidFill>
+          <a:schemeClr val="phClr"/>
+        </a:solidFill>
+        <a:gradFill rotWithShape="1">
+          <a:gsLst>
+            <a:gs pos="0">
+              <a:schemeClr val="phClr">
+                <a:lumMod val="110000"/>
+                <a:satMod val="105000"/>
+                <a:tint val="67000"/>
+              </a:schemeClr>
+            </a:gs>
+            <a:gs pos="50000">
+              <a:schemeClr val="phClr">
+                <a:lumMod val="105000"/>
+                <a:satMod val="103000"/>
+                <a:tint val="73000"/>
+              </a:schemeClr>
+            </a:gs>
+            <a:gs pos="100000">
+              <a:schemeClr val="phClr">
+                <a:lumMod val="105000"/>
+                <a:satMod val="109000"/>
+                <a:tint val="81000"/>
+              </a:schemeClr>
+            </a:gs>
+          </a:gsLst>
+          <a:lin ang="5400000" scaled="0"/>
+        </a:gradFill>
+        <a:gradFill rotWithShape="1">
+          <a:gsLst>
+            <a:gs pos="0">
+              <a:schemeClr val="phClr">
+                <a:satMod val="103000"/>
+                <a:lumMod val="102000"/>
+                <a:tint val="94000"/>
+              </a:schemeClr>
+            </a:gs>
+            <a:gs pos="50000">
+              <a:schemeClr val="phClr">
+                <a:satMod val="110000"/>
+                <a:lumMod val="100000"/>
+                <a:shade val="100000"/>
+              </a:schemeClr>
+            </a:gs>
+            <a:gs pos="100000">
+              <a:schemeClr val="phClr">
+                <a:lumMod val="99000"/>
+                <a:satMod val="120000"/>
+                <a:shade val="78000"/>
+              </a:schemeClr>
+            </a:gs>
+          </a:gsLst>
+          <a:lin ang="5400000" scaled="0"/>
+        </a:gradFill>
+      </a:fillStyleLst>
+      <a:lnStyleLst>
+        <a:ln w="6350" cap="flat" cmpd="sng" algn="ctr">
+          <a:solidFill>
+            <a:schemeClr val="phClr"/>
+          </a:solidFill>
+          <a:prstDash val="solid"/>
+          <a:miter lim="800000"/>
+        </a:ln>
+        <a:ln w="12700" cap="flat" cmpd="sng" algn="ctr">
+          <a:solidFill>
+            <a:schemeClr val="phClr"/>
+          </a:solidFill>
+          <a:prstDash val="solid"/>
+          <a:miter lim="800000"/>
+        </a:ln>
+        <a:ln w="19050" cap="flat" cmpd="sng" algn="ctr">
+          <a:solidFill>
+            <a:schemeClr val="phClr"/>
+          </a:solidFill>
+          <a:prstDash val="solid"/>
+          <a:miter lim="800000"/>
+        </a:ln>
+      </a:lnStyleLst>
+      <a:effectStyleLst>
+        <a:effectStyle>
+          <a:effectLst/>
+        </a:effectStyle>
+        <a:effectStyle>
+          <a:effectLst/>
+        </a:effectStyle>
+        <a:effectStyle>
+          <a:effectLst>
+            <a:outerShdw blurRad="57150" dist="19050" dir="5400000" algn="ctr" rotWithShape="0">
+              <a:srgbClr val="000000">
+                <a:alpha val="63000"/>
+              </a:srgbClr>
+            </a:outerShdw>
+          </a:effectLst>
+        </a:effectStyle>
+      </a:effectStyleLst>
+      <a:bgFillStyleLst>
+        <a:solidFill>
+          <a:schemeClr val="phClr"/>
+        </a:solidFill>
+        <a:solidFill>
+          <a:schemeClr val="phClr">
+            <a:tint val="95000"/>
+            <a:satMod val="170000"/>
+          </a:schemeClr>
+        </a:solidFill>
+        <a:gradFill rotWithShape="1">
+          <a:gsLst>
+            <a:gs pos="0">
+              <a:schemeClr val="phClr">
+                <a:tint val="93000"/>
+                <a:satMod val="150000"/>
+                <a:shade val="98000"/>
+                <a:lumMod val="102000"/>
+              </a:schemeClr>
+            </a:gs>
+            <a:gs pos="50000">
+              <a:schemeClr val="phClr">
+                <a:tint val="98000"/>
+                <a:satMod val="130000"/>
+                <a:shade val="90000"/>
+                <a:lumMod val="103000"/>
+              </a:schemeClr>
+            </a:gs>
+            <a:gs pos="100000">
+              <a:schemeClr val="phClr">
+                <a:shade val="63000"/>
+                <a:satMod val="120000"/>
+              </a:schemeClr>
+            </a:gs>
+          </a:gsLst>
+          <a:lin ang="5400000" scaled="0"/>
+        </a:gradFill>
+      </a:bgFillStyleLst>
+    </a:fmtScheme>
+  </a:themeElements>
+  <a:objectDefaults/>
+  <a:extraClrSchemeLst/>
+  <a:extLst>
+    <a:ext uri="{05A4C25C-085E-4340-85A3-A5531E510DB2}">
+      <thm15:themeFamily xmlns:thm15="http://schemas.microsoft.com/office/thememl/2012/main" name="Office Theme" id="{62F939B6-93AF-4DB8-9C6B-D6C7DFDC589F}" vid="{4A3C46E8-61CC-4603-A589-7422A47A8E4A}"/>
+    </a:ext>
+  </a:extLst>
+</a:theme>
 </file>
</xml_diff>